<commit_message>
Add Java Lava website concept with project details and styling
</commit_message>
<xml_diff>
--- a/mockups/kaila-marketplace/presentation/KAILA_Detailed_To_Do_List_with_Templates_and_Forms_Presentation.pptx
+++ b/mockups/kaila-marketplace/presentation/KAILA_Detailed_To_Do_List_with_Templates_and_Forms_Presentation.pptx
@@ -6183,6 +6183,10 @@
             <a:prstDash val="solid"/>
           </a:ln>
         </p:spPr>
+        <p:txBody>
+          <a:bodyPr/>
+          <a:p/>
+        </p:txBody>
       </p:sp>
       <p:sp>
         <p:nvSpPr>
@@ -6208,6 +6212,10 @@
             <a:prstDash val="solid"/>
           </a:ln>
         </p:spPr>
+        <p:txBody>
+          <a:bodyPr/>
+          <a:p/>
+        </p:txBody>
       </p:sp>
       <p:sp>
         <p:nvSpPr>
@@ -6356,6 +6364,10 @@
             <a:prstDash val="solid"/>
           </a:ln>
         </p:spPr>
+        <p:txBody>
+          <a:bodyPr/>
+          <a:p/>
+        </p:txBody>
       </p:sp>
       <p:sp>
         <p:nvSpPr>
@@ -6455,6 +6467,10 @@
             <a:prstDash val="solid"/>
           </a:ln>
         </p:spPr>
+        <p:txBody>
+          <a:bodyPr/>
+          <a:p/>
+        </p:txBody>
       </p:sp>
       <p:sp>
         <p:nvSpPr>
@@ -6554,6 +6570,10 @@
             <a:prstDash val="solid"/>
           </a:ln>
         </p:spPr>
+        <p:txBody>
+          <a:bodyPr/>
+          <a:p/>
+        </p:txBody>
       </p:sp>
       <p:sp>
         <p:nvSpPr>
@@ -6790,6 +6810,10 @@
             <a:prstDash val="solid"/>
           </a:ln>
         </p:spPr>
+        <p:txBody>
+          <a:bodyPr/>
+          <a:p/>
+        </p:txBody>
       </p:sp>
       <p:sp>
         <p:nvSpPr>
@@ -7223,6 +7247,10 @@
             <a:prstDash val="solid"/>
           </a:ln>
         </p:spPr>
+        <p:txBody>
+          <a:bodyPr/>
+          <a:p/>
+        </p:txBody>
       </p:sp>
       <p:sp>
         <p:nvSpPr>
@@ -7449,6 +7477,10 @@
             <a:prstDash val="solid"/>
           </a:ln>
         </p:spPr>
+        <p:txBody>
+          <a:bodyPr/>
+          <a:p/>
+        </p:txBody>
       </p:sp>
       <p:sp>
         <p:nvSpPr>
@@ -7558,6 +7590,10 @@
             <a:prstDash val="solid"/>
           </a:ln>
         </p:spPr>
+        <p:txBody>
+          <a:bodyPr/>
+          <a:p/>
+        </p:txBody>
       </p:sp>
       <p:sp>
         <p:nvSpPr>
@@ -7667,6 +7703,10 @@
             <a:prstDash val="solid"/>
           </a:ln>
         </p:spPr>
+        <p:txBody>
+          <a:bodyPr/>
+          <a:p/>
+        </p:txBody>
       </p:sp>
       <p:sp>
         <p:nvSpPr>
@@ -7776,6 +7816,10 @@
             <a:prstDash val="solid"/>
           </a:ln>
         </p:spPr>
+        <p:txBody>
+          <a:bodyPr/>
+          <a:p/>
+        </p:txBody>
       </p:sp>
       <p:sp>
         <p:nvSpPr>
@@ -7908,6 +7952,10 @@
             <a:prstDash val="solid"/>
           </a:ln>
         </p:spPr>
+        <p:txBody>
+          <a:bodyPr/>
+          <a:p/>
+        </p:txBody>
       </p:sp>
       <p:sp>
         <p:nvSpPr>
@@ -8290,6 +8338,10 @@
             <a:prstDash val="solid"/>
           </a:ln>
         </p:spPr>
+        <p:txBody>
+          <a:bodyPr/>
+          <a:p/>
+        </p:txBody>
       </p:sp>
       <p:sp>
         <p:nvSpPr>
@@ -8397,6 +8449,10 @@
             <a:prstDash val="solid"/>
           </a:ln>
         </p:spPr>
+        <p:txBody>
+          <a:bodyPr/>
+          <a:p/>
+        </p:txBody>
       </p:sp>
       <p:sp>
         <p:nvSpPr>
@@ -8504,6 +8560,10 @@
             <a:prstDash val="solid"/>
           </a:ln>
         </p:spPr>
+        <p:txBody>
+          <a:bodyPr/>
+          <a:p/>
+        </p:txBody>
       </p:sp>
       <p:sp>
         <p:nvSpPr>
@@ -8611,6 +8671,10 @@
             <a:prstDash val="solid"/>
           </a:ln>
         </p:spPr>
+        <p:txBody>
+          <a:bodyPr/>
+          <a:p/>
+        </p:txBody>
       </p:sp>
       <p:sp>
         <p:nvSpPr>
@@ -8718,6 +8782,10 @@
             <a:prstDash val="solid"/>
           </a:ln>
         </p:spPr>
+        <p:txBody>
+          <a:bodyPr/>
+          <a:p/>
+        </p:txBody>
       </p:sp>
     </p:spTree>
   </p:cSld>
@@ -8768,6 +8836,10 @@
             <a:prstDash val="solid"/>
           </a:ln>
         </p:spPr>
+        <p:txBody>
+          <a:bodyPr/>
+          <a:p/>
+        </p:txBody>
       </p:sp>
       <p:sp>
         <p:nvSpPr>
@@ -9201,6 +9273,10 @@
             <a:prstDash val="solid"/>
           </a:ln>
         </p:spPr>
+        <p:txBody>
+          <a:bodyPr/>
+          <a:p/>
+        </p:txBody>
       </p:sp>
       <p:sp>
         <p:nvSpPr>
@@ -9427,6 +9503,10 @@
             <a:prstDash val="solid"/>
           </a:ln>
         </p:spPr>
+        <p:txBody>
+          <a:bodyPr/>
+          <a:p/>
+        </p:txBody>
       </p:sp>
       <p:sp>
         <p:nvSpPr>
@@ -9536,6 +9616,10 @@
             <a:prstDash val="solid"/>
           </a:ln>
         </p:spPr>
+        <p:txBody>
+          <a:bodyPr/>
+          <a:p/>
+        </p:txBody>
       </p:sp>
       <p:sp>
         <p:nvSpPr>
@@ -9645,6 +9729,10 @@
             <a:prstDash val="solid"/>
           </a:ln>
         </p:spPr>
+        <p:txBody>
+          <a:bodyPr/>
+          <a:p/>
+        </p:txBody>
       </p:sp>
       <p:sp>
         <p:nvSpPr>
@@ -9754,6 +9842,10 @@
             <a:prstDash val="solid"/>
           </a:ln>
         </p:spPr>
+        <p:txBody>
+          <a:bodyPr/>
+          <a:p/>
+        </p:txBody>
       </p:sp>
       <p:sp>
         <p:nvSpPr>
@@ -9863,6 +9955,10 @@
             <a:prstDash val="solid"/>
           </a:ln>
         </p:spPr>
+        <p:txBody>
+          <a:bodyPr/>
+          <a:p/>
+        </p:txBody>
       </p:sp>
       <p:sp>
         <p:nvSpPr>
@@ -9995,6 +10091,10 @@
             <a:prstDash val="solid"/>
           </a:ln>
         </p:spPr>
+        <p:txBody>
+          <a:bodyPr/>
+          <a:p/>
+        </p:txBody>
       </p:sp>
       <p:sp>
         <p:nvSpPr>
@@ -10219,6 +10319,10 @@
             <a:prstDash val="solid"/>
           </a:ln>
         </p:spPr>
+        <p:txBody>
+          <a:bodyPr/>
+          <a:p/>
+        </p:txBody>
       </p:sp>
       <p:sp>
         <p:nvSpPr>
@@ -10356,6 +10460,10 @@
             <a:prstDash val="solid"/>
           </a:ln>
         </p:spPr>
+        <p:txBody>
+          <a:bodyPr/>
+          <a:p/>
+        </p:txBody>
       </p:sp>
       <p:sp>
         <p:nvSpPr>
@@ -10493,6 +10601,10 @@
             <a:prstDash val="solid"/>
           </a:ln>
         </p:spPr>
+        <p:txBody>
+          <a:bodyPr/>
+          <a:p/>
+        </p:txBody>
       </p:sp>
       <p:sp>
         <p:nvSpPr>
@@ -10630,6 +10742,10 @@
             <a:prstDash val="solid"/>
           </a:ln>
         </p:spPr>
+        <p:txBody>
+          <a:bodyPr/>
+          <a:p/>
+        </p:txBody>
       </p:sp>
       <p:sp>
         <p:nvSpPr>
@@ -10767,6 +10883,10 @@
             <a:prstDash val="solid"/>
           </a:ln>
         </p:spPr>
+        <p:txBody>
+          <a:bodyPr/>
+          <a:p/>
+        </p:txBody>
       </p:sp>
       <p:sp>
         <p:nvSpPr>
@@ -10904,6 +11024,10 @@
             <a:prstDash val="solid"/>
           </a:ln>
         </p:spPr>
+        <p:txBody>
+          <a:bodyPr/>
+          <a:p/>
+        </p:txBody>
       </p:sp>
       <p:sp>
         <p:nvSpPr>
@@ -11104,6 +11228,10 @@
             <a:prstDash val="solid"/>
           </a:ln>
         </p:spPr>
+        <p:txBody>
+          <a:bodyPr/>
+          <a:p/>
+        </p:txBody>
       </p:sp>
       <p:sp>
         <p:nvSpPr>
@@ -11486,6 +11614,10 @@
             <a:prstDash val="solid"/>
           </a:ln>
         </p:spPr>
+        <p:txBody>
+          <a:bodyPr/>
+          <a:p/>
+        </p:txBody>
       </p:sp>
       <p:sp>
         <p:nvSpPr>
@@ -11593,6 +11725,10 @@
             <a:prstDash val="solid"/>
           </a:ln>
         </p:spPr>
+        <p:txBody>
+          <a:bodyPr/>
+          <a:p/>
+        </p:txBody>
       </p:sp>
       <p:sp>
         <p:nvSpPr>
@@ -11700,6 +11836,10 @@
             <a:prstDash val="solid"/>
           </a:ln>
         </p:spPr>
+        <p:txBody>
+          <a:bodyPr/>
+          <a:p/>
+        </p:txBody>
       </p:sp>
       <p:sp>
         <p:nvSpPr>
@@ -11807,6 +11947,10 @@
             <a:prstDash val="solid"/>
           </a:ln>
         </p:spPr>
+        <p:txBody>
+          <a:bodyPr/>
+          <a:p/>
+        </p:txBody>
       </p:sp>
       <p:sp>
         <p:nvSpPr>
@@ -11914,6 +12058,10 @@
             <a:prstDash val="solid"/>
           </a:ln>
         </p:spPr>
+        <p:txBody>
+          <a:bodyPr/>
+          <a:p/>
+        </p:txBody>
       </p:sp>
       <p:sp>
         <p:nvSpPr>
@@ -12021,6 +12169,10 @@
             <a:prstDash val="solid"/>
           </a:ln>
         </p:spPr>
+        <p:txBody>
+          <a:bodyPr/>
+          <a:p/>
+        </p:txBody>
       </p:sp>
       <p:sp>
         <p:nvSpPr>
@@ -12128,6 +12280,10 @@
             <a:prstDash val="solid"/>
           </a:ln>
         </p:spPr>
+        <p:txBody>
+          <a:bodyPr/>
+          <a:p/>
+        </p:txBody>
       </p:sp>
       <p:sp>
         <p:nvSpPr>
@@ -12235,6 +12391,10 @@
             <a:prstDash val="solid"/>
           </a:ln>
         </p:spPr>
+        <p:txBody>
+          <a:bodyPr/>
+          <a:p/>
+        </p:txBody>
       </p:sp>
     </p:spTree>
   </p:cSld>
@@ -12285,6 +12445,10 @@
             <a:prstDash val="solid"/>
           </a:ln>
         </p:spPr>
+        <p:txBody>
+          <a:bodyPr/>
+          <a:p/>
+        </p:txBody>
       </p:sp>
       <p:sp>
         <p:nvSpPr>
@@ -12667,6 +12831,10 @@
             <a:prstDash val="solid"/>
           </a:ln>
         </p:spPr>
+        <p:txBody>
+          <a:bodyPr/>
+          <a:p/>
+        </p:txBody>
       </p:sp>
       <p:sp>
         <p:nvSpPr>
@@ -12774,6 +12942,10 @@
             <a:prstDash val="solid"/>
           </a:ln>
         </p:spPr>
+        <p:txBody>
+          <a:bodyPr/>
+          <a:p/>
+        </p:txBody>
       </p:sp>
       <p:sp>
         <p:nvSpPr>
@@ -12881,6 +13053,10 @@
             <a:prstDash val="solid"/>
           </a:ln>
         </p:spPr>
+        <p:txBody>
+          <a:bodyPr/>
+          <a:p/>
+        </p:txBody>
       </p:sp>
     </p:spTree>
   </p:cSld>
@@ -12931,6 +13107,10 @@
             <a:prstDash val="solid"/>
           </a:ln>
         </p:spPr>
+        <p:txBody>
+          <a:bodyPr/>
+          <a:p/>
+        </p:txBody>
       </p:sp>
       <p:sp>
         <p:nvSpPr>
@@ -13313,6 +13493,10 @@
             <a:prstDash val="solid"/>
           </a:ln>
         </p:spPr>
+        <p:txBody>
+          <a:bodyPr/>
+          <a:p/>
+        </p:txBody>
       </p:sp>
       <p:sp>
         <p:nvSpPr>
@@ -13420,6 +13604,10 @@
             <a:prstDash val="solid"/>
           </a:ln>
         </p:spPr>
+        <p:txBody>
+          <a:bodyPr/>
+          <a:p/>
+        </p:txBody>
       </p:sp>
       <p:sp>
         <p:nvSpPr>
@@ -13527,6 +13715,10 @@
             <a:prstDash val="solid"/>
           </a:ln>
         </p:spPr>
+        <p:txBody>
+          <a:bodyPr/>
+          <a:p/>
+        </p:txBody>
       </p:sp>
       <p:sp>
         <p:nvSpPr>
@@ -13634,6 +13826,10 @@
             <a:prstDash val="solid"/>
           </a:ln>
         </p:spPr>
+        <p:txBody>
+          <a:bodyPr/>
+          <a:p/>
+        </p:txBody>
       </p:sp>
     </p:spTree>
   </p:cSld>
@@ -13684,6 +13880,10 @@
             <a:prstDash val="solid"/>
           </a:ln>
         </p:spPr>
+        <p:txBody>
+          <a:bodyPr/>
+          <a:p/>
+        </p:txBody>
       </p:sp>
       <p:sp>
         <p:nvSpPr>
@@ -14066,6 +14266,10 @@
             <a:prstDash val="solid"/>
           </a:ln>
         </p:spPr>
+        <p:txBody>
+          <a:bodyPr/>
+          <a:p/>
+        </p:txBody>
       </p:sp>
       <p:sp>
         <p:nvSpPr>
@@ -14173,6 +14377,10 @@
             <a:prstDash val="solid"/>
           </a:ln>
         </p:spPr>
+        <p:txBody>
+          <a:bodyPr/>
+          <a:p/>
+        </p:txBody>
       </p:sp>
       <p:sp>
         <p:nvSpPr>
@@ -14280,6 +14488,10 @@
             <a:prstDash val="solid"/>
           </a:ln>
         </p:spPr>
+        <p:txBody>
+          <a:bodyPr/>
+          <a:p/>
+        </p:txBody>
       </p:sp>
       <p:sp>
         <p:nvSpPr>
@@ -14387,6 +14599,10 @@
             <a:prstDash val="solid"/>
           </a:ln>
         </p:spPr>
+        <p:txBody>
+          <a:bodyPr/>
+          <a:p/>
+        </p:txBody>
       </p:sp>
     </p:spTree>
   </p:cSld>
@@ -14437,6 +14653,10 @@
             <a:prstDash val="solid"/>
           </a:ln>
         </p:spPr>
+        <p:txBody>
+          <a:bodyPr/>
+          <a:p/>
+        </p:txBody>
       </p:sp>
       <p:sp>
         <p:nvSpPr>
@@ -14665,71 +14885,24 @@
               <a:buChar char="•"/>
             </a:pPr>
             <a:r>
-              <a:rPr lang="en-US" sz="1850" dirty="0">
-                <a:solidFill>
-                  <a:srgbClr val="17324D"/>
-                </a:solidFill>
-                <a:latin typeface="Aptos" pitchFamily="34" charset="0"/>
-                <a:ea typeface="Aptos" pitchFamily="34" charset="-122"/>
-                <a:cs typeface="Aptos" pitchFamily="34" charset="-120"/>
-              </a:rPr>
               <a:t>Use Section 1 as the startup execution guide for the first 90 days.</a:t>
             </a:r>
             <a:endParaRPr lang="en-US" sz="1850" dirty="0"/>
           </a:p>
           <a:p>
-            <a:pPr marL="203200" indent="-203200">
-              <a:buSzPct val="100000"/>
-              <a:buChar char="•"/>
-            </a:pPr>
-            <a:r>
-              <a:rPr lang="en-US" sz="1850" dirty="0">
-                <a:solidFill>
-                  <a:srgbClr val="17324D"/>
-                </a:solidFill>
-                <a:latin typeface="Aptos" pitchFamily="34" charset="0"/>
-                <a:ea typeface="Aptos" pitchFamily="34" charset="-122"/>
-                <a:cs typeface="Aptos" pitchFamily="34" charset="-120"/>
-              </a:rPr>
-              <a:t>Use Section 2 as the complete templates/forms pack for Google Forms, Google Sheets, Messenger, and meetings.</a:t>
-            </a:r>
-            <a:endParaRPr lang="en-US" sz="1850" dirty="0"/>
-          </a:p>
-          <a:p>
-            <a:pPr marL="203200" indent="-203200">
-              <a:buSzPct val="100000"/>
-              <a:buChar char="•"/>
-            </a:pPr>
-            <a:r>
-              <a:rPr lang="en-US" sz="1850" dirty="0">
-                <a:solidFill>
-                  <a:srgbClr val="17324D"/>
-                </a:solidFill>
-                <a:latin typeface="Aptos" pitchFamily="34" charset="0"/>
-                <a:ea typeface="Aptos" pitchFamily="34" charset="-122"/>
-                <a:cs typeface="Aptos" pitchFamily="34" charset="-120"/>
-              </a:rPr>
+            <a:r>
+              <a:t>Use Section 2 as the complete templates/forms pack for in-app forms, Google Sheets, Messenger, and meetings.</a:t>
+            </a:r>
+          </a:p>
+          <a:p>
+            <a:r>
               <a:t>Copy each form field exactly, then adjust local wording if needed.</a:t>
             </a:r>
-            <a:endParaRPr lang="en-US" sz="1850" dirty="0"/>
-          </a:p>
-          <a:p>
-            <a:pPr marL="203200" indent="-203200">
-              <a:buSzPct val="100000"/>
-              <a:buChar char="•"/>
-            </a:pPr>
-            <a:r>
-              <a:rPr lang="en-US" sz="1850" dirty="0">
-                <a:solidFill>
-                  <a:srgbClr val="17324D"/>
-                </a:solidFill>
-                <a:latin typeface="Aptos" pitchFamily="34" charset="0"/>
-                <a:ea typeface="Aptos" pitchFamily="34" charset="-122"/>
-                <a:cs typeface="Aptos" pitchFamily="34" charset="-120"/>
-              </a:rPr>
+          </a:p>
+          <a:p>
+            <a:r>
               <a:t>Keep this deck as the operating playbook during the concierge pilot.</a:t>
             </a:r>
-            <a:endParaRPr lang="en-US" sz="1850" dirty="0"/>
           </a:p>
         </p:txBody>
       </p:sp>
@@ -14782,6 +14955,10 @@
             <a:prstDash val="solid"/>
           </a:ln>
         </p:spPr>
+        <p:txBody>
+          <a:bodyPr/>
+          <a:p/>
+        </p:txBody>
       </p:sp>
       <p:sp>
         <p:nvSpPr>
@@ -15008,6 +15185,10 @@
             <a:prstDash val="solid"/>
           </a:ln>
         </p:spPr>
+        <p:txBody>
+          <a:bodyPr/>
+          <a:p/>
+        </p:txBody>
       </p:sp>
       <p:sp>
         <p:nvSpPr>
@@ -15117,6 +15298,10 @@
             <a:prstDash val="solid"/>
           </a:ln>
         </p:spPr>
+        <p:txBody>
+          <a:bodyPr/>
+          <a:p/>
+        </p:txBody>
       </p:sp>
       <p:sp>
         <p:nvSpPr>
@@ -15226,6 +15411,10 @@
             <a:prstDash val="solid"/>
           </a:ln>
         </p:spPr>
+        <p:txBody>
+          <a:bodyPr/>
+          <a:p/>
+        </p:txBody>
       </p:sp>
       <p:sp>
         <p:nvSpPr>
@@ -15335,6 +15524,10 @@
             <a:prstDash val="solid"/>
           </a:ln>
         </p:spPr>
+        <p:txBody>
+          <a:bodyPr/>
+          <a:p/>
+        </p:txBody>
       </p:sp>
       <p:sp>
         <p:nvSpPr>
@@ -15444,6 +15637,10 @@
             <a:prstDash val="solid"/>
           </a:ln>
         </p:spPr>
+        <p:txBody>
+          <a:bodyPr/>
+          <a:p/>
+        </p:txBody>
       </p:sp>
       <p:sp>
         <p:nvSpPr>
@@ -15553,6 +15750,10 @@
             <a:prstDash val="solid"/>
           </a:ln>
         </p:spPr>
+        <p:txBody>
+          <a:bodyPr/>
+          <a:p/>
+        </p:txBody>
       </p:sp>
       <p:sp>
         <p:nvSpPr>
@@ -15685,6 +15886,10 @@
             <a:prstDash val="solid"/>
           </a:ln>
         </p:spPr>
+        <p:txBody>
+          <a:bodyPr/>
+          <a:p/>
+        </p:txBody>
       </p:sp>
       <p:sp>
         <p:nvSpPr>
@@ -16118,6 +16323,10 @@
             <a:prstDash val="solid"/>
           </a:ln>
         </p:spPr>
+        <p:txBody>
+          <a:bodyPr/>
+          <a:p/>
+        </p:txBody>
       </p:sp>
       <p:sp>
         <p:nvSpPr>
@@ -16551,6 +16760,10 @@
             <a:prstDash val="solid"/>
           </a:ln>
         </p:spPr>
+        <p:txBody>
+          <a:bodyPr/>
+          <a:p/>
+        </p:txBody>
       </p:sp>
       <p:sp>
         <p:nvSpPr>
@@ -16967,6 +17180,10 @@
             <a:prstDash val="solid"/>
           </a:ln>
         </p:spPr>
+        <p:txBody>
+          <a:bodyPr/>
+          <a:p/>
+        </p:txBody>
       </p:sp>
       <p:sp>
         <p:nvSpPr>
@@ -17193,6 +17410,10 @@
             <a:prstDash val="solid"/>
           </a:ln>
         </p:spPr>
+        <p:txBody>
+          <a:bodyPr/>
+          <a:p/>
+        </p:txBody>
       </p:sp>
       <p:sp>
         <p:nvSpPr>
@@ -17302,6 +17523,10 @@
             <a:prstDash val="solid"/>
           </a:ln>
         </p:spPr>
+        <p:txBody>
+          <a:bodyPr/>
+          <a:p/>
+        </p:txBody>
       </p:sp>
       <p:sp>
         <p:nvSpPr>
@@ -17411,6 +17636,10 @@
             <a:prstDash val="solid"/>
           </a:ln>
         </p:spPr>
+        <p:txBody>
+          <a:bodyPr/>
+          <a:p/>
+        </p:txBody>
       </p:sp>
       <p:sp>
         <p:nvSpPr>
@@ -17520,6 +17749,10 @@
             <a:prstDash val="solid"/>
           </a:ln>
         </p:spPr>
+        <p:txBody>
+          <a:bodyPr/>
+          <a:p/>
+        </p:txBody>
       </p:sp>
       <p:sp>
         <p:nvSpPr>
@@ -17629,6 +17862,10 @@
             <a:prstDash val="solid"/>
           </a:ln>
         </p:spPr>
+        <p:txBody>
+          <a:bodyPr/>
+          <a:p/>
+        </p:txBody>
       </p:sp>
       <p:sp>
         <p:nvSpPr>
@@ -17738,6 +17975,10 @@
             <a:prstDash val="solid"/>
           </a:ln>
         </p:spPr>
+        <p:txBody>
+          <a:bodyPr/>
+          <a:p/>
+        </p:txBody>
       </p:sp>
       <p:sp>
         <p:nvSpPr>
@@ -17879,6 +18120,10 @@
             <a:prstDash val="solid"/>
           </a:ln>
         </p:spPr>
+        <p:txBody>
+          <a:bodyPr/>
+          <a:p/>
+        </p:txBody>
       </p:sp>
       <p:sp>
         <p:nvSpPr>
@@ -17904,6 +18149,10 @@
             <a:prstDash val="solid"/>
           </a:ln>
         </p:spPr>
+        <p:txBody>
+          <a:bodyPr/>
+          <a:p/>
+        </p:txBody>
       </p:sp>
       <p:sp>
         <p:nvSpPr>
@@ -17929,6 +18178,10 @@
             <a:prstDash val="solid"/>
           </a:ln>
         </p:spPr>
+        <p:txBody>
+          <a:bodyPr/>
+          <a:p/>
+        </p:txBody>
       </p:sp>
       <p:sp>
         <p:nvSpPr>
@@ -18247,6 +18500,10 @@
             <a:prstDash val="solid"/>
           </a:ln>
         </p:spPr>
+        <p:txBody>
+          <a:bodyPr/>
+          <a:p/>
+        </p:txBody>
       </p:sp>
       <p:sp>
         <p:nvSpPr>
@@ -18355,15 +18612,7 @@
               <a:buNone/>
             </a:pPr>
             <a:r>
-              <a:rPr lang="en-US" sz="1550" dirty="0">
-                <a:solidFill>
-                  <a:srgbClr val="5A6B7A"/>
-                </a:solidFill>
-                <a:latin typeface="Aptos" pitchFamily="34" charset="0"/>
-                <a:ea typeface="Aptos" pitchFamily="34" charset="-122"/>
-                <a:cs typeface="Aptos" pitchFamily="34" charset="-120"/>
-              </a:rPr>
-              <a:t>Copy these templates into Google Forms, Google Sheets, Messenger, and meeting notes.</a:t>
+              <a:t>Use the in-app forms first; keep these templates as backup for Sheets, Messenger, and meeting notes.</a:t>
             </a:r>
             <a:endParaRPr lang="en-US" sz="1550" dirty="0"/>
           </a:p>
@@ -18610,6 +18859,10 @@
             <a:prstDash val="solid"/>
           </a:ln>
         </p:spPr>
+        <p:txBody>
+          <a:bodyPr/>
+          <a:p/>
+        </p:txBody>
       </p:sp>
       <p:sp>
         <p:nvSpPr>
@@ -18718,15 +18971,7 @@
               <a:buNone/>
             </a:pPr>
             <a:r>
-              <a:rPr lang="en-US" sz="1550" dirty="0">
-                <a:solidFill>
-                  <a:srgbClr val="5A6B7A"/>
-                </a:solidFill>
-                <a:latin typeface="Aptos" pitchFamily="34" charset="0"/>
-                <a:ea typeface="Aptos" pitchFamily="34" charset="-122"/>
-                <a:cs typeface="Aptos" pitchFamily="34" charset="-120"/>
-              </a:rPr>
-              <a:t>Copy into Google Forms. Use this to collect basic provider identity and contact details.</a:t>
+              <a:t>Use the in-app form; keep this as backup. Use this to collect basic provider identity and contact details.</a:t>
             </a:r>
             <a:endParaRPr lang="en-US" sz="1550" dirty="0"/>
           </a:p>
@@ -18992,6 +19237,10 @@
             <a:prstDash val="solid"/>
           </a:ln>
         </p:spPr>
+        <p:txBody>
+          <a:bodyPr/>
+          <a:p/>
+        </p:txBody>
       </p:sp>
       <p:sp>
         <p:nvSpPr>
@@ -19099,6 +19348,10 @@
             <a:prstDash val="solid"/>
           </a:ln>
         </p:spPr>
+        <p:txBody>
+          <a:bodyPr/>
+          <a:p/>
+        </p:txBody>
       </p:sp>
       <p:sp>
         <p:nvSpPr>
@@ -19206,6 +19459,10 @@
             <a:prstDash val="solid"/>
           </a:ln>
         </p:spPr>
+        <p:txBody>
+          <a:bodyPr/>
+          <a:p/>
+        </p:txBody>
       </p:sp>
       <p:sp>
         <p:nvSpPr>
@@ -19313,6 +19570,10 @@
             <a:prstDash val="solid"/>
           </a:ln>
         </p:spPr>
+        <p:txBody>
+          <a:bodyPr/>
+          <a:p/>
+        </p:txBody>
       </p:sp>
       <p:sp>
         <p:nvSpPr>
@@ -19420,6 +19681,10 @@
             <a:prstDash val="solid"/>
           </a:ln>
         </p:spPr>
+        <p:txBody>
+          <a:bodyPr/>
+          <a:p/>
+        </p:txBody>
       </p:sp>
       <p:sp>
         <p:nvSpPr>
@@ -19527,6 +19792,10 @@
             <a:prstDash val="solid"/>
           </a:ln>
         </p:spPr>
+        <p:txBody>
+          <a:bodyPr/>
+          <a:p/>
+        </p:txBody>
       </p:sp>
       <p:sp>
         <p:nvSpPr>
@@ -19634,6 +19903,10 @@
             <a:prstDash val="solid"/>
           </a:ln>
         </p:spPr>
+        <p:txBody>
+          <a:bodyPr/>
+          <a:p/>
+        </p:txBody>
       </p:sp>
       <p:sp>
         <p:nvSpPr>
@@ -19741,6 +20014,10 @@
             <a:prstDash val="solid"/>
           </a:ln>
         </p:spPr>
+        <p:txBody>
+          <a:bodyPr/>
+          <a:p/>
+        </p:txBody>
       </p:sp>
     </p:spTree>
   </p:cSld>
@@ -19791,6 +20068,10 @@
             <a:prstDash val="solid"/>
           </a:ln>
         </p:spPr>
+        <p:txBody>
+          <a:bodyPr/>
+          <a:p/>
+        </p:txBody>
       </p:sp>
       <p:sp>
         <p:nvSpPr>
@@ -20173,6 +20454,10 @@
             <a:prstDash val="solid"/>
           </a:ln>
         </p:spPr>
+        <p:txBody>
+          <a:bodyPr/>
+          <a:p/>
+        </p:txBody>
       </p:sp>
       <p:sp>
         <p:nvSpPr>
@@ -20280,6 +20565,10 @@
             <a:prstDash val="solid"/>
           </a:ln>
         </p:spPr>
+        <p:txBody>
+          <a:bodyPr/>
+          <a:p/>
+        </p:txBody>
       </p:sp>
       <p:sp>
         <p:nvSpPr>
@@ -20387,6 +20676,10 @@
             <a:prstDash val="solid"/>
           </a:ln>
         </p:spPr>
+        <p:txBody>
+          <a:bodyPr/>
+          <a:p/>
+        </p:txBody>
       </p:sp>
       <p:sp>
         <p:nvSpPr>
@@ -20494,6 +20787,10 @@
             <a:prstDash val="solid"/>
           </a:ln>
         </p:spPr>
+        <p:txBody>
+          <a:bodyPr/>
+          <a:p/>
+        </p:txBody>
       </p:sp>
       <p:sp>
         <p:nvSpPr>
@@ -20601,6 +20898,10 @@
             <a:prstDash val="solid"/>
           </a:ln>
         </p:spPr>
+        <p:txBody>
+          <a:bodyPr/>
+          <a:p/>
+        </p:txBody>
       </p:sp>
       <p:sp>
         <p:nvSpPr>
@@ -20708,6 +21009,10 @@
             <a:prstDash val="solid"/>
           </a:ln>
         </p:spPr>
+        <p:txBody>
+          <a:bodyPr/>
+          <a:p/>
+        </p:txBody>
       </p:sp>
       <p:sp>
         <p:nvSpPr>
@@ -20815,6 +21120,10 @@
             <a:prstDash val="solid"/>
           </a:ln>
         </p:spPr>
+        <p:txBody>
+          <a:bodyPr/>
+          <a:p/>
+        </p:txBody>
       </p:sp>
       <p:sp>
         <p:nvSpPr>
@@ -20922,6 +21231,10 @@
             <a:prstDash val="solid"/>
           </a:ln>
         </p:spPr>
+        <p:txBody>
+          <a:bodyPr/>
+          <a:p/>
+        </p:txBody>
       </p:sp>
     </p:spTree>
   </p:cSld>
@@ -20972,6 +21285,10 @@
             <a:prstDash val="solid"/>
           </a:ln>
         </p:spPr>
+        <p:txBody>
+          <a:bodyPr/>
+          <a:p/>
+        </p:txBody>
       </p:sp>
       <p:sp>
         <p:nvSpPr>
@@ -21354,6 +21671,10 @@
             <a:prstDash val="solid"/>
           </a:ln>
         </p:spPr>
+        <p:txBody>
+          <a:bodyPr/>
+          <a:p/>
+        </p:txBody>
       </p:sp>
       <p:sp>
         <p:nvSpPr>
@@ -21461,6 +21782,10 @@
             <a:prstDash val="solid"/>
           </a:ln>
         </p:spPr>
+        <p:txBody>
+          <a:bodyPr/>
+          <a:p/>
+        </p:txBody>
       </p:sp>
       <p:sp>
         <p:nvSpPr>
@@ -21568,6 +21893,10 @@
             <a:prstDash val="solid"/>
           </a:ln>
         </p:spPr>
+        <p:txBody>
+          <a:bodyPr/>
+          <a:p/>
+        </p:txBody>
       </p:sp>
       <p:sp>
         <p:nvSpPr>
@@ -21675,6 +22004,10 @@
             <a:prstDash val="solid"/>
           </a:ln>
         </p:spPr>
+        <p:txBody>
+          <a:bodyPr/>
+          <a:p/>
+        </p:txBody>
       </p:sp>
       <p:sp>
         <p:nvSpPr>
@@ -21782,6 +22115,10 @@
             <a:prstDash val="solid"/>
           </a:ln>
         </p:spPr>
+        <p:txBody>
+          <a:bodyPr/>
+          <a:p/>
+        </p:txBody>
       </p:sp>
       <p:sp>
         <p:nvSpPr>
@@ -21889,6 +22226,10 @@
             <a:prstDash val="solid"/>
           </a:ln>
         </p:spPr>
+        <p:txBody>
+          <a:bodyPr/>
+          <a:p/>
+        </p:txBody>
       </p:sp>
       <p:sp>
         <p:nvSpPr>
@@ -21996,6 +22337,10 @@
             <a:prstDash val="solid"/>
           </a:ln>
         </p:spPr>
+        <p:txBody>
+          <a:bodyPr/>
+          <a:p/>
+        </p:txBody>
       </p:sp>
       <p:sp>
         <p:nvSpPr>
@@ -22103,6 +22448,10 @@
             <a:prstDash val="solid"/>
           </a:ln>
         </p:spPr>
+        <p:txBody>
+          <a:bodyPr/>
+          <a:p/>
+        </p:txBody>
       </p:sp>
     </p:spTree>
   </p:cSld>
@@ -22162,6 +22511,10 @@
             <a:prstDash val="solid"/>
           </a:ln>
         </p:spPr>
+        <p:txBody>
+          <a:bodyPr/>
+          <a:p/>
+        </p:txBody>
       </p:sp>
       <p:sp>
         <p:nvSpPr>
@@ -22187,6 +22540,10 @@
             <a:prstDash val="solid"/>
           </a:ln>
         </p:spPr>
+        <p:txBody>
+          <a:bodyPr/>
+          <a:p/>
+        </p:txBody>
       </p:sp>
       <p:sp>
         <p:nvSpPr>
@@ -22212,6 +22569,10 @@
             <a:prstDash val="solid"/>
           </a:ln>
         </p:spPr>
+        <p:txBody>
+          <a:bodyPr/>
+          <a:p/>
+        </p:txBody>
       </p:sp>
       <p:sp>
         <p:nvSpPr>
@@ -22530,6 +22891,10 @@
             <a:prstDash val="solid"/>
           </a:ln>
         </p:spPr>
+        <p:txBody>
+          <a:bodyPr/>
+          <a:p/>
+        </p:txBody>
       </p:sp>
       <p:sp>
         <p:nvSpPr>
@@ -22912,6 +23277,10 @@
             <a:prstDash val="solid"/>
           </a:ln>
         </p:spPr>
+        <p:txBody>
+          <a:bodyPr/>
+          <a:p/>
+        </p:txBody>
       </p:sp>
       <p:sp>
         <p:nvSpPr>
@@ -23019,6 +23388,10 @@
             <a:prstDash val="solid"/>
           </a:ln>
         </p:spPr>
+        <p:txBody>
+          <a:bodyPr/>
+          <a:p/>
+        </p:txBody>
       </p:sp>
       <p:sp>
         <p:nvSpPr>
@@ -23126,6 +23499,10 @@
             <a:prstDash val="solid"/>
           </a:ln>
         </p:spPr>
+        <p:txBody>
+          <a:bodyPr/>
+          <a:p/>
+        </p:txBody>
       </p:sp>
       <p:sp>
         <p:nvSpPr>
@@ -23233,6 +23610,10 @@
             <a:prstDash val="solid"/>
           </a:ln>
         </p:spPr>
+        <p:txBody>
+          <a:bodyPr/>
+          <a:p/>
+        </p:txBody>
       </p:sp>
       <p:sp>
         <p:nvSpPr>
@@ -23340,6 +23721,10 @@
             <a:prstDash val="solid"/>
           </a:ln>
         </p:spPr>
+        <p:txBody>
+          <a:bodyPr/>
+          <a:p/>
+        </p:txBody>
       </p:sp>
       <p:sp>
         <p:nvSpPr>
@@ -23447,6 +23832,10 @@
             <a:prstDash val="solid"/>
           </a:ln>
         </p:spPr>
+        <p:txBody>
+          <a:bodyPr/>
+          <a:p/>
+        </p:txBody>
       </p:sp>
       <p:sp>
         <p:nvSpPr>
@@ -23554,6 +23943,10 @@
             <a:prstDash val="solid"/>
           </a:ln>
         </p:spPr>
+        <p:txBody>
+          <a:bodyPr/>
+          <a:p/>
+        </p:txBody>
       </p:sp>
       <p:sp>
         <p:nvSpPr>
@@ -23661,6 +24054,10 @@
             <a:prstDash val="solid"/>
           </a:ln>
         </p:spPr>
+        <p:txBody>
+          <a:bodyPr/>
+          <a:p/>
+        </p:txBody>
       </p:sp>
     </p:spTree>
   </p:cSld>
@@ -23711,6 +24108,10 @@
             <a:prstDash val="solid"/>
           </a:ln>
         </p:spPr>
+        <p:txBody>
+          <a:bodyPr/>
+          <a:p/>
+        </p:txBody>
       </p:sp>
       <p:sp>
         <p:nvSpPr>
@@ -24093,6 +24494,10 @@
             <a:prstDash val="solid"/>
           </a:ln>
         </p:spPr>
+        <p:txBody>
+          <a:bodyPr/>
+          <a:p/>
+        </p:txBody>
       </p:sp>
       <p:sp>
         <p:nvSpPr>
@@ -24200,6 +24605,10 @@
             <a:prstDash val="solid"/>
           </a:ln>
         </p:spPr>
+        <p:txBody>
+          <a:bodyPr/>
+          <a:p/>
+        </p:txBody>
       </p:sp>
       <p:sp>
         <p:nvSpPr>
@@ -24307,6 +24716,10 @@
             <a:prstDash val="solid"/>
           </a:ln>
         </p:spPr>
+        <p:txBody>
+          <a:bodyPr/>
+          <a:p/>
+        </p:txBody>
       </p:sp>
       <p:sp>
         <p:nvSpPr>
@@ -24414,6 +24827,10 @@
             <a:prstDash val="solid"/>
           </a:ln>
         </p:spPr>
+        <p:txBody>
+          <a:bodyPr/>
+          <a:p/>
+        </p:txBody>
       </p:sp>
       <p:sp>
         <p:nvSpPr>
@@ -24521,6 +24938,10 @@
             <a:prstDash val="solid"/>
           </a:ln>
         </p:spPr>
+        <p:txBody>
+          <a:bodyPr/>
+          <a:p/>
+        </p:txBody>
       </p:sp>
       <p:sp>
         <p:nvSpPr>
@@ -24628,6 +25049,10 @@
             <a:prstDash val="solid"/>
           </a:ln>
         </p:spPr>
+        <p:txBody>
+          <a:bodyPr/>
+          <a:p/>
+        </p:txBody>
       </p:sp>
       <p:sp>
         <p:nvSpPr>
@@ -24735,6 +25160,10 @@
             <a:prstDash val="solid"/>
           </a:ln>
         </p:spPr>
+        <p:txBody>
+          <a:bodyPr/>
+          <a:p/>
+        </p:txBody>
       </p:sp>
       <p:sp>
         <p:nvSpPr>
@@ -24842,6 +25271,10 @@
             <a:prstDash val="solid"/>
           </a:ln>
         </p:spPr>
+        <p:txBody>
+          <a:bodyPr/>
+          <a:p/>
+        </p:txBody>
       </p:sp>
     </p:spTree>
   </p:cSld>
@@ -24892,6 +25325,10 @@
             <a:prstDash val="solid"/>
           </a:ln>
         </p:spPr>
+        <p:txBody>
+          <a:bodyPr/>
+          <a:p/>
+        </p:txBody>
       </p:sp>
       <p:sp>
         <p:nvSpPr>
@@ -25000,15 +25437,7 @@
               <a:buNone/>
             </a:pPr>
             <a:r>
-              <a:rPr lang="en-US" sz="1550" dirty="0">
-                <a:solidFill>
-                  <a:srgbClr val="5A6B7A"/>
-                </a:solidFill>
-                <a:latin typeface="Aptos" pitchFamily="34" charset="0"/>
-                <a:ea typeface="Aptos" pitchFamily="34" charset="-122"/>
-                <a:cs typeface="Aptos" pitchFamily="34" charset="-120"/>
-              </a:rPr>
-              <a:t>Copy into Google Forms. Use this to collect clear service requests.</a:t>
+              <a:t>Use the in-app form; keep this as backup. Use this to collect clear service requests.</a:t>
             </a:r>
             <a:endParaRPr lang="en-US" sz="1550" dirty="0"/>
           </a:p>
@@ -25274,6 +25703,10 @@
             <a:prstDash val="solid"/>
           </a:ln>
         </p:spPr>
+        <p:txBody>
+          <a:bodyPr/>
+          <a:p/>
+        </p:txBody>
       </p:sp>
       <p:sp>
         <p:nvSpPr>
@@ -25381,6 +25814,10 @@
             <a:prstDash val="solid"/>
           </a:ln>
         </p:spPr>
+        <p:txBody>
+          <a:bodyPr/>
+          <a:p/>
+        </p:txBody>
       </p:sp>
       <p:sp>
         <p:nvSpPr>
@@ -25488,6 +25925,10 @@
             <a:prstDash val="solid"/>
           </a:ln>
         </p:spPr>
+        <p:txBody>
+          <a:bodyPr/>
+          <a:p/>
+        </p:txBody>
       </p:sp>
       <p:sp>
         <p:nvSpPr>
@@ -25595,6 +26036,10 @@
             <a:prstDash val="solid"/>
           </a:ln>
         </p:spPr>
+        <p:txBody>
+          <a:bodyPr/>
+          <a:p/>
+        </p:txBody>
       </p:sp>
       <p:sp>
         <p:nvSpPr>
@@ -25702,6 +26147,10 @@
             <a:prstDash val="solid"/>
           </a:ln>
         </p:spPr>
+        <p:txBody>
+          <a:bodyPr/>
+          <a:p/>
+        </p:txBody>
       </p:sp>
       <p:sp>
         <p:nvSpPr>
@@ -25809,6 +26258,10 @@
             <a:prstDash val="solid"/>
           </a:ln>
         </p:spPr>
+        <p:txBody>
+          <a:bodyPr/>
+          <a:p/>
+        </p:txBody>
       </p:sp>
       <p:sp>
         <p:nvSpPr>
@@ -25916,6 +26369,10 @@
             <a:prstDash val="solid"/>
           </a:ln>
         </p:spPr>
+        <p:txBody>
+          <a:bodyPr/>
+          <a:p/>
+        </p:txBody>
       </p:sp>
       <p:sp>
         <p:nvSpPr>
@@ -26023,6 +26480,10 @@
             <a:prstDash val="solid"/>
           </a:ln>
         </p:spPr>
+        <p:txBody>
+          <a:bodyPr/>
+          <a:p/>
+        </p:txBody>
       </p:sp>
     </p:spTree>
   </p:cSld>
@@ -26073,6 +26534,10 @@
             <a:prstDash val="solid"/>
           </a:ln>
         </p:spPr>
+        <p:txBody>
+          <a:bodyPr/>
+          <a:p/>
+        </p:txBody>
       </p:sp>
       <p:sp>
         <p:nvSpPr>
@@ -26455,6 +26920,10 @@
             <a:prstDash val="solid"/>
           </a:ln>
         </p:spPr>
+        <p:txBody>
+          <a:bodyPr/>
+          <a:p/>
+        </p:txBody>
       </p:sp>
       <p:sp>
         <p:nvSpPr>
@@ -26562,6 +27031,10 @@
             <a:prstDash val="solid"/>
           </a:ln>
         </p:spPr>
+        <p:txBody>
+          <a:bodyPr/>
+          <a:p/>
+        </p:txBody>
       </p:sp>
       <p:sp>
         <p:nvSpPr>
@@ -26669,6 +27142,10 @@
             <a:prstDash val="solid"/>
           </a:ln>
         </p:spPr>
+        <p:txBody>
+          <a:bodyPr/>
+          <a:p/>
+        </p:txBody>
       </p:sp>
       <p:sp>
         <p:nvSpPr>
@@ -26776,6 +27253,10 @@
             <a:prstDash val="solid"/>
           </a:ln>
         </p:spPr>
+        <p:txBody>
+          <a:bodyPr/>
+          <a:p/>
+        </p:txBody>
       </p:sp>
       <p:sp>
         <p:nvSpPr>
@@ -26883,6 +27364,10 @@
             <a:prstDash val="solid"/>
           </a:ln>
         </p:spPr>
+        <p:txBody>
+          <a:bodyPr/>
+          <a:p/>
+        </p:txBody>
       </p:sp>
       <p:sp>
         <p:nvSpPr>
@@ -26990,6 +27475,10 @@
             <a:prstDash val="solid"/>
           </a:ln>
         </p:spPr>
+        <p:txBody>
+          <a:bodyPr/>
+          <a:p/>
+        </p:txBody>
       </p:sp>
       <p:sp>
         <p:nvSpPr>
@@ -27097,6 +27586,10 @@
             <a:prstDash val="solid"/>
           </a:ln>
         </p:spPr>
+        <p:txBody>
+          <a:bodyPr/>
+          <a:p/>
+        </p:txBody>
       </p:sp>
       <p:sp>
         <p:nvSpPr>
@@ -27204,6 +27697,10 @@
             <a:prstDash val="solid"/>
           </a:ln>
         </p:spPr>
+        <p:txBody>
+          <a:bodyPr/>
+          <a:p/>
+        </p:txBody>
       </p:sp>
     </p:spTree>
   </p:cSld>
@@ -27254,6 +27751,10 @@
             <a:prstDash val="solid"/>
           </a:ln>
         </p:spPr>
+        <p:txBody>
+          <a:bodyPr/>
+          <a:p/>
+        </p:txBody>
       </p:sp>
       <p:sp>
         <p:nvSpPr>
@@ -27636,6 +28137,10 @@
             <a:prstDash val="solid"/>
           </a:ln>
         </p:spPr>
+        <p:txBody>
+          <a:bodyPr/>
+          <a:p/>
+        </p:txBody>
       </p:sp>
       <p:sp>
         <p:nvSpPr>
@@ -27743,6 +28248,10 @@
             <a:prstDash val="solid"/>
           </a:ln>
         </p:spPr>
+        <p:txBody>
+          <a:bodyPr/>
+          <a:p/>
+        </p:txBody>
       </p:sp>
       <p:sp>
         <p:nvSpPr>
@@ -27850,6 +28359,10 @@
             <a:prstDash val="solid"/>
           </a:ln>
         </p:spPr>
+        <p:txBody>
+          <a:bodyPr/>
+          <a:p/>
+        </p:txBody>
       </p:sp>
       <p:sp>
         <p:nvSpPr>
@@ -27957,6 +28470,10 @@
             <a:prstDash val="solid"/>
           </a:ln>
         </p:spPr>
+        <p:txBody>
+          <a:bodyPr/>
+          <a:p/>
+        </p:txBody>
       </p:sp>
       <p:sp>
         <p:nvSpPr>
@@ -28064,6 +28581,10 @@
             <a:prstDash val="solid"/>
           </a:ln>
         </p:spPr>
+        <p:txBody>
+          <a:bodyPr/>
+          <a:p/>
+        </p:txBody>
       </p:sp>
       <p:sp>
         <p:nvSpPr>
@@ -28171,6 +28692,10 @@
             <a:prstDash val="solid"/>
           </a:ln>
         </p:spPr>
+        <p:txBody>
+          <a:bodyPr/>
+          <a:p/>
+        </p:txBody>
       </p:sp>
       <p:sp>
         <p:nvSpPr>
@@ -28278,6 +28803,10 @@
             <a:prstDash val="solid"/>
           </a:ln>
         </p:spPr>
+        <p:txBody>
+          <a:bodyPr/>
+          <a:p/>
+        </p:txBody>
       </p:sp>
       <p:sp>
         <p:nvSpPr>
@@ -28385,6 +28914,10 @@
             <a:prstDash val="solid"/>
           </a:ln>
         </p:spPr>
+        <p:txBody>
+          <a:bodyPr/>
+          <a:p/>
+        </p:txBody>
       </p:sp>
     </p:spTree>
   </p:cSld>
@@ -28435,6 +28968,10 @@
             <a:prstDash val="solid"/>
           </a:ln>
         </p:spPr>
+        <p:txBody>
+          <a:bodyPr/>
+          <a:p/>
+        </p:txBody>
       </p:sp>
       <p:sp>
         <p:nvSpPr>
@@ -28817,6 +29354,10 @@
             <a:prstDash val="solid"/>
           </a:ln>
         </p:spPr>
+        <p:txBody>
+          <a:bodyPr/>
+          <a:p/>
+        </p:txBody>
       </p:sp>
       <p:sp>
         <p:nvSpPr>
@@ -28924,6 +29465,10 @@
             <a:prstDash val="solid"/>
           </a:ln>
         </p:spPr>
+        <p:txBody>
+          <a:bodyPr/>
+          <a:p/>
+        </p:txBody>
       </p:sp>
       <p:sp>
         <p:nvSpPr>
@@ -29031,6 +29576,10 @@
             <a:prstDash val="solid"/>
           </a:ln>
         </p:spPr>
+        <p:txBody>
+          <a:bodyPr/>
+          <a:p/>
+        </p:txBody>
       </p:sp>
       <p:sp>
         <p:nvSpPr>
@@ -29138,6 +29687,10 @@
             <a:prstDash val="solid"/>
           </a:ln>
         </p:spPr>
+        <p:txBody>
+          <a:bodyPr/>
+          <a:p/>
+        </p:txBody>
       </p:sp>
       <p:sp>
         <p:nvSpPr>
@@ -29245,6 +29798,10 @@
             <a:prstDash val="solid"/>
           </a:ln>
         </p:spPr>
+        <p:txBody>
+          <a:bodyPr/>
+          <a:p/>
+        </p:txBody>
       </p:sp>
       <p:sp>
         <p:nvSpPr>
@@ -29352,6 +29909,10 @@
             <a:prstDash val="solid"/>
           </a:ln>
         </p:spPr>
+        <p:txBody>
+          <a:bodyPr/>
+          <a:p/>
+        </p:txBody>
       </p:sp>
       <p:sp>
         <p:nvSpPr>
@@ -29459,6 +30020,10 @@
             <a:prstDash val="solid"/>
           </a:ln>
         </p:spPr>
+        <p:txBody>
+          <a:bodyPr/>
+          <a:p/>
+        </p:txBody>
       </p:sp>
       <p:sp>
         <p:nvSpPr>
@@ -29566,6 +30131,10 @@
             <a:prstDash val="solid"/>
           </a:ln>
         </p:spPr>
+        <p:txBody>
+          <a:bodyPr/>
+          <a:p/>
+        </p:txBody>
       </p:sp>
     </p:spTree>
   </p:cSld>
@@ -29616,6 +30185,10 @@
             <a:prstDash val="solid"/>
           </a:ln>
         </p:spPr>
+        <p:txBody>
+          <a:bodyPr/>
+          <a:p/>
+        </p:txBody>
       </p:sp>
       <p:sp>
         <p:nvSpPr>
@@ -29998,6 +30571,10 @@
             <a:prstDash val="solid"/>
           </a:ln>
         </p:spPr>
+        <p:txBody>
+          <a:bodyPr/>
+          <a:p/>
+        </p:txBody>
       </p:sp>
       <p:sp>
         <p:nvSpPr>
@@ -30105,6 +30682,10 @@
             <a:prstDash val="solid"/>
           </a:ln>
         </p:spPr>
+        <p:txBody>
+          <a:bodyPr/>
+          <a:p/>
+        </p:txBody>
       </p:sp>
       <p:sp>
         <p:nvSpPr>
@@ -30212,6 +30793,10 @@
             <a:prstDash val="solid"/>
           </a:ln>
         </p:spPr>
+        <p:txBody>
+          <a:bodyPr/>
+          <a:p/>
+        </p:txBody>
       </p:sp>
       <p:sp>
         <p:nvSpPr>
@@ -30319,6 +30904,10 @@
             <a:prstDash val="solid"/>
           </a:ln>
         </p:spPr>
+        <p:txBody>
+          <a:bodyPr/>
+          <a:p/>
+        </p:txBody>
       </p:sp>
       <p:sp>
         <p:nvSpPr>
@@ -30426,6 +31015,10 @@
             <a:prstDash val="solid"/>
           </a:ln>
         </p:spPr>
+        <p:txBody>
+          <a:bodyPr/>
+          <a:p/>
+        </p:txBody>
       </p:sp>
       <p:sp>
         <p:nvSpPr>
@@ -30533,6 +31126,10 @@
             <a:prstDash val="solid"/>
           </a:ln>
         </p:spPr>
+        <p:txBody>
+          <a:bodyPr/>
+          <a:p/>
+        </p:txBody>
       </p:sp>
       <p:sp>
         <p:nvSpPr>
@@ -30640,6 +31237,10 @@
             <a:prstDash val="solid"/>
           </a:ln>
         </p:spPr>
+        <p:txBody>
+          <a:bodyPr/>
+          <a:p/>
+        </p:txBody>
       </p:sp>
       <p:sp>
         <p:nvSpPr>
@@ -30747,6 +31348,10 @@
             <a:prstDash val="solid"/>
           </a:ln>
         </p:spPr>
+        <p:txBody>
+          <a:bodyPr/>
+          <a:p/>
+        </p:txBody>
       </p:sp>
     </p:spTree>
   </p:cSld>
@@ -30797,6 +31402,10 @@
             <a:prstDash val="solid"/>
           </a:ln>
         </p:spPr>
+        <p:txBody>
+          <a:bodyPr/>
+          <a:p/>
+        </p:txBody>
       </p:sp>
       <p:sp>
         <p:nvSpPr>
@@ -31179,6 +31788,10 @@
             <a:prstDash val="solid"/>
           </a:ln>
         </p:spPr>
+        <p:txBody>
+          <a:bodyPr/>
+          <a:p/>
+        </p:txBody>
       </p:sp>
       <p:sp>
         <p:nvSpPr>
@@ -31286,6 +31899,10 @@
             <a:prstDash val="solid"/>
           </a:ln>
         </p:spPr>
+        <p:txBody>
+          <a:bodyPr/>
+          <a:p/>
+        </p:txBody>
       </p:sp>
       <p:sp>
         <p:nvSpPr>
@@ -31393,6 +32010,10 @@
             <a:prstDash val="solid"/>
           </a:ln>
         </p:spPr>
+        <p:txBody>
+          <a:bodyPr/>
+          <a:p/>
+        </p:txBody>
       </p:sp>
       <p:sp>
         <p:nvSpPr>
@@ -31500,6 +32121,10 @@
             <a:prstDash val="solid"/>
           </a:ln>
         </p:spPr>
+        <p:txBody>
+          <a:bodyPr/>
+          <a:p/>
+        </p:txBody>
       </p:sp>
       <p:sp>
         <p:nvSpPr>
@@ -31607,6 +32232,10 @@
             <a:prstDash val="solid"/>
           </a:ln>
         </p:spPr>
+        <p:txBody>
+          <a:bodyPr/>
+          <a:p/>
+        </p:txBody>
       </p:sp>
       <p:sp>
         <p:nvSpPr>
@@ -31714,6 +32343,10 @@
             <a:prstDash val="solid"/>
           </a:ln>
         </p:spPr>
+        <p:txBody>
+          <a:bodyPr/>
+          <a:p/>
+        </p:txBody>
       </p:sp>
       <p:sp>
         <p:nvSpPr>
@@ -31821,6 +32454,10 @@
             <a:prstDash val="solid"/>
           </a:ln>
         </p:spPr>
+        <p:txBody>
+          <a:bodyPr/>
+          <a:p/>
+        </p:txBody>
       </p:sp>
       <p:sp>
         <p:nvSpPr>
@@ -31928,6 +32565,10 @@
             <a:prstDash val="solid"/>
           </a:ln>
         </p:spPr>
+        <p:txBody>
+          <a:bodyPr/>
+          <a:p/>
+        </p:txBody>
       </p:sp>
     </p:spTree>
   </p:cSld>
@@ -31978,6 +32619,10 @@
             <a:prstDash val="solid"/>
           </a:ln>
         </p:spPr>
+        <p:txBody>
+          <a:bodyPr/>
+          <a:p/>
+        </p:txBody>
       </p:sp>
       <p:sp>
         <p:nvSpPr>
@@ -32360,6 +33005,10 @@
             <a:prstDash val="solid"/>
           </a:ln>
         </p:spPr>
+        <p:txBody>
+          <a:bodyPr/>
+          <a:p/>
+        </p:txBody>
       </p:sp>
       <p:sp>
         <p:nvSpPr>
@@ -32467,6 +33116,10 @@
             <a:prstDash val="solid"/>
           </a:ln>
         </p:spPr>
+        <p:txBody>
+          <a:bodyPr/>
+          <a:p/>
+        </p:txBody>
       </p:sp>
       <p:sp>
         <p:nvSpPr>
@@ -32574,6 +33227,10 @@
             <a:prstDash val="solid"/>
           </a:ln>
         </p:spPr>
+        <p:txBody>
+          <a:bodyPr/>
+          <a:p/>
+        </p:txBody>
       </p:sp>
       <p:sp>
         <p:nvSpPr>
@@ -32681,6 +33338,10 @@
             <a:prstDash val="solid"/>
           </a:ln>
         </p:spPr>
+        <p:txBody>
+          <a:bodyPr/>
+          <a:p/>
+        </p:txBody>
       </p:sp>
       <p:sp>
         <p:nvSpPr>
@@ -32788,6 +33449,10 @@
             <a:prstDash val="solid"/>
           </a:ln>
         </p:spPr>
+        <p:txBody>
+          <a:bodyPr/>
+          <a:p/>
+        </p:txBody>
       </p:sp>
       <p:sp>
         <p:nvSpPr>
@@ -32895,6 +33560,10 @@
             <a:prstDash val="solid"/>
           </a:ln>
         </p:spPr>
+        <p:txBody>
+          <a:bodyPr/>
+          <a:p/>
+        </p:txBody>
       </p:sp>
       <p:sp>
         <p:nvSpPr>
@@ -33002,6 +33671,10 @@
             <a:prstDash val="solid"/>
           </a:ln>
         </p:spPr>
+        <p:txBody>
+          <a:bodyPr/>
+          <a:p/>
+        </p:txBody>
       </p:sp>
       <p:sp>
         <p:nvSpPr>
@@ -33109,6 +33782,10 @@
             <a:prstDash val="solid"/>
           </a:ln>
         </p:spPr>
+        <p:txBody>
+          <a:bodyPr/>
+          <a:p/>
+        </p:txBody>
       </p:sp>
     </p:spTree>
   </p:cSld>
@@ -33159,6 +33836,10 @@
             <a:prstDash val="solid"/>
           </a:ln>
         </p:spPr>
+        <p:txBody>
+          <a:bodyPr/>
+          <a:p/>
+        </p:txBody>
       </p:sp>
       <p:sp>
         <p:nvSpPr>
@@ -33541,6 +34222,10 @@
             <a:prstDash val="solid"/>
           </a:ln>
         </p:spPr>
+        <p:txBody>
+          <a:bodyPr/>
+          <a:p/>
+        </p:txBody>
       </p:sp>
       <p:sp>
         <p:nvSpPr>
@@ -33648,6 +34333,10 @@
             <a:prstDash val="solid"/>
           </a:ln>
         </p:spPr>
+        <p:txBody>
+          <a:bodyPr/>
+          <a:p/>
+        </p:txBody>
       </p:sp>
       <p:sp>
         <p:nvSpPr>
@@ -33755,6 +34444,10 @@
             <a:prstDash val="solid"/>
           </a:ln>
         </p:spPr>
+        <p:txBody>
+          <a:bodyPr/>
+          <a:p/>
+        </p:txBody>
       </p:sp>
       <p:sp>
         <p:nvSpPr>
@@ -33862,6 +34555,10 @@
             <a:prstDash val="solid"/>
           </a:ln>
         </p:spPr>
+        <p:txBody>
+          <a:bodyPr/>
+          <a:p/>
+        </p:txBody>
       </p:sp>
       <p:sp>
         <p:nvSpPr>
@@ -33969,6 +34666,10 @@
             <a:prstDash val="solid"/>
           </a:ln>
         </p:spPr>
+        <p:txBody>
+          <a:bodyPr/>
+          <a:p/>
+        </p:txBody>
       </p:sp>
       <p:sp>
         <p:nvSpPr>
@@ -34076,6 +34777,10 @@
             <a:prstDash val="solid"/>
           </a:ln>
         </p:spPr>
+        <p:txBody>
+          <a:bodyPr/>
+          <a:p/>
+        </p:txBody>
       </p:sp>
       <p:sp>
         <p:nvSpPr>
@@ -34183,6 +34888,10 @@
             <a:prstDash val="solid"/>
           </a:ln>
         </p:spPr>
+        <p:txBody>
+          <a:bodyPr/>
+          <a:p/>
+        </p:txBody>
       </p:sp>
       <p:sp>
         <p:nvSpPr>
@@ -34290,6 +34999,10 @@
             <a:prstDash val="solid"/>
           </a:ln>
         </p:spPr>
+        <p:txBody>
+          <a:bodyPr/>
+          <a:p/>
+        </p:txBody>
       </p:sp>
     </p:spTree>
   </p:cSld>
@@ -34340,6 +35053,10 @@
             <a:prstDash val="solid"/>
           </a:ln>
         </p:spPr>
+        <p:txBody>
+          <a:bodyPr/>
+          <a:p/>
+        </p:txBody>
       </p:sp>
       <p:sp>
         <p:nvSpPr>
@@ -34566,6 +35283,10 @@
             <a:prstDash val="solid"/>
           </a:ln>
         </p:spPr>
+        <p:txBody>
+          <a:bodyPr/>
+          <a:p/>
+        </p:txBody>
       </p:sp>
       <p:sp>
         <p:nvSpPr>
@@ -34675,6 +35396,10 @@
             <a:prstDash val="solid"/>
           </a:ln>
         </p:spPr>
+        <p:txBody>
+          <a:bodyPr/>
+          <a:p/>
+        </p:txBody>
       </p:sp>
       <p:sp>
         <p:nvSpPr>
@@ -34784,6 +35509,10 @@
             <a:prstDash val="solid"/>
           </a:ln>
         </p:spPr>
+        <p:txBody>
+          <a:bodyPr/>
+          <a:p/>
+        </p:txBody>
       </p:sp>
       <p:sp>
         <p:nvSpPr>
@@ -34916,6 +35645,10 @@
             <a:prstDash val="solid"/>
           </a:ln>
         </p:spPr>
+        <p:txBody>
+          <a:bodyPr/>
+          <a:p/>
+        </p:txBody>
       </p:sp>
       <p:sp>
         <p:nvSpPr>
@@ -35298,6 +36031,10 @@
             <a:prstDash val="solid"/>
           </a:ln>
         </p:spPr>
+        <p:txBody>
+          <a:bodyPr/>
+          <a:p/>
+        </p:txBody>
       </p:sp>
       <p:sp>
         <p:nvSpPr>
@@ -35405,6 +36142,10 @@
             <a:prstDash val="solid"/>
           </a:ln>
         </p:spPr>
+        <p:txBody>
+          <a:bodyPr/>
+          <a:p/>
+        </p:txBody>
       </p:sp>
       <p:sp>
         <p:nvSpPr>
@@ -35512,6 +36253,10 @@
             <a:prstDash val="solid"/>
           </a:ln>
         </p:spPr>
+        <p:txBody>
+          <a:bodyPr/>
+          <a:p/>
+        </p:txBody>
       </p:sp>
       <p:sp>
         <p:nvSpPr>
@@ -35619,6 +36364,10 @@
             <a:prstDash val="solid"/>
           </a:ln>
         </p:spPr>
+        <p:txBody>
+          <a:bodyPr/>
+          <a:p/>
+        </p:txBody>
       </p:sp>
       <p:sp>
         <p:nvSpPr>
@@ -35726,6 +36475,10 @@
             <a:prstDash val="solid"/>
           </a:ln>
         </p:spPr>
+        <p:txBody>
+          <a:bodyPr/>
+          <a:p/>
+        </p:txBody>
       </p:sp>
       <p:sp>
         <p:nvSpPr>
@@ -35833,6 +36586,10 @@
             <a:prstDash val="solid"/>
           </a:ln>
         </p:spPr>
+        <p:txBody>
+          <a:bodyPr/>
+          <a:p/>
+        </p:txBody>
       </p:sp>
       <p:sp>
         <p:nvSpPr>
@@ -35940,6 +36697,10 @@
             <a:prstDash val="solid"/>
           </a:ln>
         </p:spPr>
+        <p:txBody>
+          <a:bodyPr/>
+          <a:p/>
+        </p:txBody>
       </p:sp>
       <p:sp>
         <p:nvSpPr>
@@ -36047,6 +36808,10 @@
             <a:prstDash val="solid"/>
           </a:ln>
         </p:spPr>
+        <p:txBody>
+          <a:bodyPr/>
+          <a:p/>
+        </p:txBody>
       </p:sp>
     </p:spTree>
   </p:cSld>
@@ -36097,6 +36862,10 @@
             <a:prstDash val="solid"/>
           </a:ln>
         </p:spPr>
+        <p:txBody>
+          <a:bodyPr/>
+          <a:p/>
+        </p:txBody>
       </p:sp>
       <p:sp>
         <p:nvSpPr>
@@ -36479,6 +37248,10 @@
             <a:prstDash val="solid"/>
           </a:ln>
         </p:spPr>
+        <p:txBody>
+          <a:bodyPr/>
+          <a:p/>
+        </p:txBody>
       </p:sp>
       <p:sp>
         <p:nvSpPr>
@@ -36586,6 +37359,10 @@
             <a:prstDash val="solid"/>
           </a:ln>
         </p:spPr>
+        <p:txBody>
+          <a:bodyPr/>
+          <a:p/>
+        </p:txBody>
       </p:sp>
       <p:sp>
         <p:nvSpPr>
@@ -36693,6 +37470,10 @@
             <a:prstDash val="solid"/>
           </a:ln>
         </p:spPr>
+        <p:txBody>
+          <a:bodyPr/>
+          <a:p/>
+        </p:txBody>
       </p:sp>
       <p:sp>
         <p:nvSpPr>
@@ -36800,6 +37581,10 @@
             <a:prstDash val="solid"/>
           </a:ln>
         </p:spPr>
+        <p:txBody>
+          <a:bodyPr/>
+          <a:p/>
+        </p:txBody>
       </p:sp>
       <p:sp>
         <p:nvSpPr>
@@ -36907,6 +37692,10 @@
             <a:prstDash val="solid"/>
           </a:ln>
         </p:spPr>
+        <p:txBody>
+          <a:bodyPr/>
+          <a:p/>
+        </p:txBody>
       </p:sp>
       <p:sp>
         <p:nvSpPr>
@@ -37014,6 +37803,10 @@
             <a:prstDash val="solid"/>
           </a:ln>
         </p:spPr>
+        <p:txBody>
+          <a:bodyPr/>
+          <a:p/>
+        </p:txBody>
       </p:sp>
       <p:sp>
         <p:nvSpPr>
@@ -37121,6 +37914,10 @@
             <a:prstDash val="solid"/>
           </a:ln>
         </p:spPr>
+        <p:txBody>
+          <a:bodyPr/>
+          <a:p/>
+        </p:txBody>
       </p:sp>
       <p:sp>
         <p:nvSpPr>
@@ -37228,6 +38025,10 @@
             <a:prstDash val="solid"/>
           </a:ln>
         </p:spPr>
+        <p:txBody>
+          <a:bodyPr/>
+          <a:p/>
+        </p:txBody>
       </p:sp>
     </p:spTree>
   </p:cSld>
@@ -37278,6 +38079,10 @@
             <a:prstDash val="solid"/>
           </a:ln>
         </p:spPr>
+        <p:txBody>
+          <a:bodyPr/>
+          <a:p/>
+        </p:txBody>
       </p:sp>
       <p:sp>
         <p:nvSpPr>
@@ -37504,6 +38309,10 @@
             <a:prstDash val="solid"/>
           </a:ln>
         </p:spPr>
+        <p:txBody>
+          <a:bodyPr/>
+          <a:p/>
+        </p:txBody>
       </p:sp>
       <p:sp>
         <p:nvSpPr>
@@ -37608,6 +38417,10 @@
             <a:prstDash val="solid"/>
           </a:ln>
         </p:spPr>
+        <p:txBody>
+          <a:bodyPr/>
+          <a:p/>
+        </p:txBody>
       </p:sp>
       <p:sp>
         <p:nvSpPr>
@@ -37735,6 +38548,10 @@
             <a:prstDash val="solid"/>
           </a:ln>
         </p:spPr>
+        <p:txBody>
+          <a:bodyPr/>
+          <a:p/>
+        </p:txBody>
       </p:sp>
       <p:sp>
         <p:nvSpPr>
@@ -37961,6 +38778,10 @@
             <a:prstDash val="solid"/>
           </a:ln>
         </p:spPr>
+        <p:txBody>
+          <a:bodyPr/>
+          <a:p/>
+        </p:txBody>
       </p:sp>
       <p:sp>
         <p:nvSpPr>
@@ -38065,6 +38886,10 @@
             <a:prstDash val="solid"/>
           </a:ln>
         </p:spPr>
+        <p:txBody>
+          <a:bodyPr/>
+          <a:p/>
+        </p:txBody>
       </p:sp>
       <p:sp>
         <p:nvSpPr>
@@ -38192,6 +39017,10 @@
             <a:prstDash val="solid"/>
           </a:ln>
         </p:spPr>
+        <p:txBody>
+          <a:bodyPr/>
+          <a:p/>
+        </p:txBody>
       </p:sp>
       <p:sp>
         <p:nvSpPr>
@@ -38418,6 +39247,10 @@
             <a:prstDash val="solid"/>
           </a:ln>
         </p:spPr>
+        <p:txBody>
+          <a:bodyPr/>
+          <a:p/>
+        </p:txBody>
       </p:sp>
       <p:sp>
         <p:nvSpPr>
@@ -38624,6 +39457,10 @@
             <a:prstDash val="solid"/>
           </a:ln>
         </p:spPr>
+        <p:txBody>
+          <a:bodyPr/>
+          <a:p/>
+        </p:txBody>
       </p:sp>
       <p:sp>
         <p:nvSpPr>
@@ -38751,6 +39588,10 @@
             <a:prstDash val="solid"/>
           </a:ln>
         </p:spPr>
+        <p:txBody>
+          <a:bodyPr/>
+          <a:p/>
+        </p:txBody>
       </p:sp>
       <p:sp>
         <p:nvSpPr>
@@ -39133,6 +39974,10 @@
             <a:prstDash val="solid"/>
           </a:ln>
         </p:spPr>
+        <p:txBody>
+          <a:bodyPr/>
+          <a:p/>
+        </p:txBody>
       </p:sp>
       <p:sp>
         <p:nvSpPr>
@@ -39240,6 +40085,10 @@
             <a:prstDash val="solid"/>
           </a:ln>
         </p:spPr>
+        <p:txBody>
+          <a:bodyPr/>
+          <a:p/>
+        </p:txBody>
       </p:sp>
       <p:sp>
         <p:nvSpPr>
@@ -39347,6 +40196,10 @@
             <a:prstDash val="solid"/>
           </a:ln>
         </p:spPr>
+        <p:txBody>
+          <a:bodyPr/>
+          <a:p/>
+        </p:txBody>
       </p:sp>
       <p:sp>
         <p:nvSpPr>
@@ -39454,6 +40307,10 @@
             <a:prstDash val="solid"/>
           </a:ln>
         </p:spPr>
+        <p:txBody>
+          <a:bodyPr/>
+          <a:p/>
+        </p:txBody>
       </p:sp>
     </p:spTree>
   </p:cSld>
@@ -39504,6 +40361,10 @@
             <a:prstDash val="solid"/>
           </a:ln>
         </p:spPr>
+        <p:txBody>
+          <a:bodyPr/>
+          <a:p/>
+        </p:txBody>
       </p:sp>
       <p:sp>
         <p:nvSpPr>
@@ -39730,6 +40591,10 @@
             <a:prstDash val="solid"/>
           </a:ln>
         </p:spPr>
+        <p:txBody>
+          <a:bodyPr/>
+          <a:p/>
+        </p:txBody>
       </p:sp>
       <p:sp>
         <p:nvSpPr>
@@ -39834,6 +40699,10 @@
             <a:prstDash val="solid"/>
           </a:ln>
         </p:spPr>
+        <p:txBody>
+          <a:bodyPr/>
+          <a:p/>
+        </p:txBody>
       </p:sp>
       <p:sp>
         <p:nvSpPr>
@@ -39961,6 +40830,10 @@
             <a:prstDash val="solid"/>
           </a:ln>
         </p:spPr>
+        <p:txBody>
+          <a:bodyPr/>
+          <a:p/>
+        </p:txBody>
       </p:sp>
       <p:sp>
         <p:nvSpPr>
@@ -40394,6 +41267,10 @@
             <a:prstDash val="solid"/>
           </a:ln>
         </p:spPr>
+        <p:txBody>
+          <a:bodyPr/>
+          <a:p/>
+        </p:txBody>
       </p:sp>
       <p:sp>
         <p:nvSpPr>
@@ -40827,6 +41704,10 @@
             <a:prstDash val="solid"/>
           </a:ln>
         </p:spPr>
+        <p:txBody>
+          <a:bodyPr/>
+          <a:p/>
+        </p:txBody>
       </p:sp>
       <p:sp>
         <p:nvSpPr>
@@ -41209,6 +42090,10 @@
             <a:prstDash val="solid"/>
           </a:ln>
         </p:spPr>
+        <p:txBody>
+          <a:bodyPr/>
+          <a:p/>
+        </p:txBody>
       </p:sp>
       <p:sp>
         <p:nvSpPr>
@@ -41316,6 +42201,10 @@
             <a:prstDash val="solid"/>
           </a:ln>
         </p:spPr>
+        <p:txBody>
+          <a:bodyPr/>
+          <a:p/>
+        </p:txBody>
       </p:sp>
       <p:sp>
         <p:nvSpPr>
@@ -41423,6 +42312,10 @@
             <a:prstDash val="solid"/>
           </a:ln>
         </p:spPr>
+        <p:txBody>
+          <a:bodyPr/>
+          <a:p/>
+        </p:txBody>
       </p:sp>
       <p:sp>
         <p:nvSpPr>
@@ -41530,6 +42423,10 @@
             <a:prstDash val="solid"/>
           </a:ln>
         </p:spPr>
+        <p:txBody>
+          <a:bodyPr/>
+          <a:p/>
+        </p:txBody>
       </p:sp>
       <p:sp>
         <p:nvSpPr>
@@ -41637,6 +42534,10 @@
             <a:prstDash val="solid"/>
           </a:ln>
         </p:spPr>
+        <p:txBody>
+          <a:bodyPr/>
+          <a:p/>
+        </p:txBody>
       </p:sp>
       <p:sp>
         <p:nvSpPr>
@@ -41744,6 +42645,10 @@
             <a:prstDash val="solid"/>
           </a:ln>
         </p:spPr>
+        <p:txBody>
+          <a:bodyPr/>
+          <a:p/>
+        </p:txBody>
       </p:sp>
       <p:sp>
         <p:nvSpPr>
@@ -41851,6 +42756,10 @@
             <a:prstDash val="solid"/>
           </a:ln>
         </p:spPr>
+        <p:txBody>
+          <a:bodyPr/>
+          <a:p/>
+        </p:txBody>
       </p:sp>
       <p:sp>
         <p:nvSpPr>
@@ -41958,6 +42867,10 @@
             <a:prstDash val="solid"/>
           </a:ln>
         </p:spPr>
+        <p:txBody>
+          <a:bodyPr/>
+          <a:p/>
+        </p:txBody>
       </p:sp>
     </p:spTree>
   </p:cSld>
@@ -42008,6 +42921,10 @@
             <a:prstDash val="solid"/>
           </a:ln>
         </p:spPr>
+        <p:txBody>
+          <a:bodyPr/>
+          <a:p/>
+        </p:txBody>
       </p:sp>
       <p:sp>
         <p:nvSpPr>
@@ -42232,6 +43149,10 @@
             <a:prstDash val="solid"/>
           </a:ln>
         </p:spPr>
+        <p:txBody>
+          <a:bodyPr/>
+          <a:p/>
+        </p:txBody>
       </p:sp>
       <p:sp>
         <p:nvSpPr>
@@ -42369,6 +43290,10 @@
             <a:prstDash val="solid"/>
           </a:ln>
         </p:spPr>
+        <p:txBody>
+          <a:bodyPr/>
+          <a:p/>
+        </p:txBody>
       </p:sp>
       <p:sp>
         <p:nvSpPr>
@@ -42506,6 +43431,10 @@
             <a:prstDash val="solid"/>
           </a:ln>
         </p:spPr>
+        <p:txBody>
+          <a:bodyPr/>
+          <a:p/>
+        </p:txBody>
       </p:sp>
       <p:sp>
         <p:nvSpPr>
@@ -42643,6 +43572,10 @@
             <a:prstDash val="solid"/>
           </a:ln>
         </p:spPr>
+        <p:txBody>
+          <a:bodyPr/>
+          <a:p/>
+        </p:txBody>
       </p:sp>
       <p:sp>
         <p:nvSpPr>
@@ -42780,6 +43713,10 @@
             <a:prstDash val="solid"/>
           </a:ln>
         </p:spPr>
+        <p:txBody>
+          <a:bodyPr/>
+          <a:p/>
+        </p:txBody>
       </p:sp>
       <p:sp>
         <p:nvSpPr>
@@ -42980,6 +43917,10 @@
             <a:prstDash val="solid"/>
           </a:ln>
         </p:spPr>
+        <p:txBody>
+          <a:bodyPr/>
+          <a:p/>
+        </p:txBody>
       </p:sp>
       <p:sp>
         <p:nvSpPr>
@@ -43362,6 +44303,10 @@
             <a:prstDash val="solid"/>
           </a:ln>
         </p:spPr>
+        <p:txBody>
+          <a:bodyPr/>
+          <a:p/>
+        </p:txBody>
       </p:sp>
       <p:sp>
         <p:nvSpPr>
@@ -43469,6 +44414,10 @@
             <a:prstDash val="solid"/>
           </a:ln>
         </p:spPr>
+        <p:txBody>
+          <a:bodyPr/>
+          <a:p/>
+        </p:txBody>
       </p:sp>
       <p:sp>
         <p:nvSpPr>
@@ -43576,6 +44525,10 @@
             <a:prstDash val="solid"/>
           </a:ln>
         </p:spPr>
+        <p:txBody>
+          <a:bodyPr/>
+          <a:p/>
+        </p:txBody>
       </p:sp>
       <p:sp>
         <p:nvSpPr>
@@ -43683,6 +44636,10 @@
             <a:prstDash val="solid"/>
           </a:ln>
         </p:spPr>
+        <p:txBody>
+          <a:bodyPr/>
+          <a:p/>
+        </p:txBody>
       </p:sp>
       <p:sp>
         <p:nvSpPr>
@@ -43790,6 +44747,10 @@
             <a:prstDash val="solid"/>
           </a:ln>
         </p:spPr>
+        <p:txBody>
+          <a:bodyPr/>
+          <a:p/>
+        </p:txBody>
       </p:sp>
       <p:sp>
         <p:nvSpPr>
@@ -43897,6 +44858,10 @@
             <a:prstDash val="solid"/>
           </a:ln>
         </p:spPr>
+        <p:txBody>
+          <a:bodyPr/>
+          <a:p/>
+        </p:txBody>
       </p:sp>
       <p:sp>
         <p:nvSpPr>
@@ -44004,6 +44969,10 @@
             <a:prstDash val="solid"/>
           </a:ln>
         </p:spPr>
+        <p:txBody>
+          <a:bodyPr/>
+          <a:p/>
+        </p:txBody>
       </p:sp>
       <p:sp>
         <p:nvSpPr>
@@ -44111,6 +45080,10 @@
             <a:prstDash val="solid"/>
           </a:ln>
         </p:spPr>
+        <p:txBody>
+          <a:bodyPr/>
+          <a:p/>
+        </p:txBody>
       </p:sp>
     </p:spTree>
   </p:cSld>
@@ -44161,6 +45134,10 @@
             <a:prstDash val="solid"/>
           </a:ln>
         </p:spPr>
+        <p:txBody>
+          <a:bodyPr/>
+          <a:p/>
+        </p:txBody>
       </p:sp>
       <p:sp>
         <p:nvSpPr>
@@ -44543,6 +45520,10 @@
             <a:prstDash val="solid"/>
           </a:ln>
         </p:spPr>
+        <p:txBody>
+          <a:bodyPr/>
+          <a:p/>
+        </p:txBody>
       </p:sp>
       <p:sp>
         <p:nvSpPr>
@@ -44650,6 +45631,10 @@
             <a:prstDash val="solid"/>
           </a:ln>
         </p:spPr>
+        <p:txBody>
+          <a:bodyPr/>
+          <a:p/>
+        </p:txBody>
       </p:sp>
       <p:sp>
         <p:nvSpPr>
@@ -44757,6 +45742,10 @@
             <a:prstDash val="solid"/>
           </a:ln>
         </p:spPr>
+        <p:txBody>
+          <a:bodyPr/>
+          <a:p/>
+        </p:txBody>
       </p:sp>
       <p:sp>
         <p:nvSpPr>
@@ -44864,6 +45853,10 @@
             <a:prstDash val="solid"/>
           </a:ln>
         </p:spPr>
+        <p:txBody>
+          <a:bodyPr/>
+          <a:p/>
+        </p:txBody>
       </p:sp>
       <p:sp>
         <p:nvSpPr>
@@ -44971,6 +45964,10 @@
             <a:prstDash val="solid"/>
           </a:ln>
         </p:spPr>
+        <p:txBody>
+          <a:bodyPr/>
+          <a:p/>
+        </p:txBody>
       </p:sp>
       <p:sp>
         <p:nvSpPr>
@@ -45078,6 +46075,10 @@
             <a:prstDash val="solid"/>
           </a:ln>
         </p:spPr>
+        <p:txBody>
+          <a:bodyPr/>
+          <a:p/>
+        </p:txBody>
       </p:sp>
     </p:spTree>
   </p:cSld>
@@ -45128,6 +46129,10 @@
             <a:prstDash val="solid"/>
           </a:ln>
         </p:spPr>
+        <p:txBody>
+          <a:bodyPr/>
+          <a:p/>
+        </p:txBody>
       </p:sp>
       <p:sp>
         <p:nvSpPr>
@@ -45510,6 +46515,10 @@
             <a:prstDash val="solid"/>
           </a:ln>
         </p:spPr>
+        <p:txBody>
+          <a:bodyPr/>
+          <a:p/>
+        </p:txBody>
       </p:sp>
       <p:sp>
         <p:nvSpPr>
@@ -45617,6 +46626,10 @@
             <a:prstDash val="solid"/>
           </a:ln>
         </p:spPr>
+        <p:txBody>
+          <a:bodyPr/>
+          <a:p/>
+        </p:txBody>
       </p:sp>
       <p:sp>
         <p:nvSpPr>
@@ -45724,6 +46737,10 @@
             <a:prstDash val="solid"/>
           </a:ln>
         </p:spPr>
+        <p:txBody>
+          <a:bodyPr/>
+          <a:p/>
+        </p:txBody>
       </p:sp>
       <p:sp>
         <p:nvSpPr>
@@ -45831,6 +46848,10 @@
             <a:prstDash val="solid"/>
           </a:ln>
         </p:spPr>
+        <p:txBody>
+          <a:bodyPr/>
+          <a:p/>
+        </p:txBody>
       </p:sp>
       <p:sp>
         <p:nvSpPr>
@@ -45938,6 +46959,10 @@
             <a:prstDash val="solid"/>
           </a:ln>
         </p:spPr>
+        <p:txBody>
+          <a:bodyPr/>
+          <a:p/>
+        </p:txBody>
       </p:sp>
       <p:sp>
         <p:nvSpPr>
@@ -46045,6 +47070,10 @@
             <a:prstDash val="solid"/>
           </a:ln>
         </p:spPr>
+        <p:txBody>
+          <a:bodyPr/>
+          <a:p/>
+        </p:txBody>
       </p:sp>
     </p:spTree>
   </p:cSld>
@@ -46095,6 +47124,10 @@
             <a:prstDash val="solid"/>
           </a:ln>
         </p:spPr>
+        <p:txBody>
+          <a:bodyPr/>
+          <a:p/>
+        </p:txBody>
       </p:sp>
       <p:sp>
         <p:nvSpPr>
@@ -46477,6 +47510,10 @@
             <a:prstDash val="solid"/>
           </a:ln>
         </p:spPr>
+        <p:txBody>
+          <a:bodyPr/>
+          <a:p/>
+        </p:txBody>
       </p:sp>
       <p:sp>
         <p:nvSpPr>
@@ -46584,6 +47621,10 @@
             <a:prstDash val="solid"/>
           </a:ln>
         </p:spPr>
+        <p:txBody>
+          <a:bodyPr/>
+          <a:p/>
+        </p:txBody>
       </p:sp>
       <p:sp>
         <p:nvSpPr>
@@ -46691,6 +47732,10 @@
             <a:prstDash val="solid"/>
           </a:ln>
         </p:spPr>
+        <p:txBody>
+          <a:bodyPr/>
+          <a:p/>
+        </p:txBody>
       </p:sp>
       <p:sp>
         <p:nvSpPr>
@@ -46798,6 +47843,10 @@
             <a:prstDash val="solid"/>
           </a:ln>
         </p:spPr>
+        <p:txBody>
+          <a:bodyPr/>
+          <a:p/>
+        </p:txBody>
       </p:sp>
       <p:sp>
         <p:nvSpPr>
@@ -46905,6 +47954,10 @@
             <a:prstDash val="solid"/>
           </a:ln>
         </p:spPr>
+        <p:txBody>
+          <a:bodyPr/>
+          <a:p/>
+        </p:txBody>
       </p:sp>
       <p:sp>
         <p:nvSpPr>
@@ -47012,6 +48065,10 @@
             <a:prstDash val="solid"/>
           </a:ln>
         </p:spPr>
+        <p:txBody>
+          <a:bodyPr/>
+          <a:p/>
+        </p:txBody>
       </p:sp>
     </p:spTree>
   </p:cSld>
@@ -47062,6 +48119,10 @@
             <a:prstDash val="solid"/>
           </a:ln>
         </p:spPr>
+        <p:txBody>
+          <a:bodyPr/>
+          <a:p/>
+        </p:txBody>
       </p:sp>
       <p:sp>
         <p:nvSpPr>
@@ -47444,6 +48505,10 @@
             <a:prstDash val="solid"/>
           </a:ln>
         </p:spPr>
+        <p:txBody>
+          <a:bodyPr/>
+          <a:p/>
+        </p:txBody>
       </p:sp>
       <p:sp>
         <p:nvSpPr>
@@ -47551,6 +48616,10 @@
             <a:prstDash val="solid"/>
           </a:ln>
         </p:spPr>
+        <p:txBody>
+          <a:bodyPr/>
+          <a:p/>
+        </p:txBody>
       </p:sp>
       <p:sp>
         <p:nvSpPr>
@@ -47658,6 +48727,10 @@
             <a:prstDash val="solid"/>
           </a:ln>
         </p:spPr>
+        <p:txBody>
+          <a:bodyPr/>
+          <a:p/>
+        </p:txBody>
       </p:sp>
       <p:sp>
         <p:nvSpPr>
@@ -47765,6 +48838,10 @@
             <a:prstDash val="solid"/>
           </a:ln>
         </p:spPr>
+        <p:txBody>
+          <a:bodyPr/>
+          <a:p/>
+        </p:txBody>
       </p:sp>
       <p:sp>
         <p:nvSpPr>
@@ -47872,6 +48949,10 @@
             <a:prstDash val="solid"/>
           </a:ln>
         </p:spPr>
+        <p:txBody>
+          <a:bodyPr/>
+          <a:p/>
+        </p:txBody>
       </p:sp>
       <p:sp>
         <p:nvSpPr>
@@ -47979,6 +49060,10 @@
             <a:prstDash val="solid"/>
           </a:ln>
         </p:spPr>
+        <p:txBody>
+          <a:bodyPr/>
+          <a:p/>
+        </p:txBody>
       </p:sp>
     </p:spTree>
   </p:cSld>
@@ -48029,6 +49114,10 @@
             <a:prstDash val="solid"/>
           </a:ln>
         </p:spPr>
+        <p:txBody>
+          <a:bodyPr/>
+          <a:p/>
+        </p:txBody>
       </p:sp>
       <p:sp>
         <p:nvSpPr>
@@ -48411,6 +49500,10 @@
             <a:prstDash val="solid"/>
           </a:ln>
         </p:spPr>
+        <p:txBody>
+          <a:bodyPr/>
+          <a:p/>
+        </p:txBody>
       </p:sp>
       <p:sp>
         <p:nvSpPr>
@@ -48518,6 +49611,10 @@
             <a:prstDash val="solid"/>
           </a:ln>
         </p:spPr>
+        <p:txBody>
+          <a:bodyPr/>
+          <a:p/>
+        </p:txBody>
       </p:sp>
       <p:sp>
         <p:nvSpPr>
@@ -48625,6 +49722,10 @@
             <a:prstDash val="solid"/>
           </a:ln>
         </p:spPr>
+        <p:txBody>
+          <a:bodyPr/>
+          <a:p/>
+        </p:txBody>
       </p:sp>
       <p:sp>
         <p:nvSpPr>
@@ -48732,6 +49833,10 @@
             <a:prstDash val="solid"/>
           </a:ln>
         </p:spPr>
+        <p:txBody>
+          <a:bodyPr/>
+          <a:p/>
+        </p:txBody>
       </p:sp>
       <p:sp>
         <p:nvSpPr>
@@ -48839,6 +49944,10 @@
             <a:prstDash val="solid"/>
           </a:ln>
         </p:spPr>
+        <p:txBody>
+          <a:bodyPr/>
+          <a:p/>
+        </p:txBody>
       </p:sp>
       <p:sp>
         <p:nvSpPr>
@@ -48946,6 +50055,10 @@
             <a:prstDash val="solid"/>
           </a:ln>
         </p:spPr>
+        <p:txBody>
+          <a:bodyPr/>
+          <a:p/>
+        </p:txBody>
       </p:sp>
       <p:sp>
         <p:nvSpPr>
@@ -49053,6 +50166,10 @@
             <a:prstDash val="solid"/>
           </a:ln>
         </p:spPr>
+        <p:txBody>
+          <a:bodyPr/>
+          <a:p/>
+        </p:txBody>
       </p:sp>
     </p:spTree>
   </p:cSld>
@@ -49103,6 +50220,10 @@
             <a:prstDash val="solid"/>
           </a:ln>
         </p:spPr>
+        <p:txBody>
+          <a:bodyPr/>
+          <a:p/>
+        </p:txBody>
       </p:sp>
       <p:sp>
         <p:nvSpPr>
@@ -49485,6 +50606,10 @@
             <a:prstDash val="solid"/>
           </a:ln>
         </p:spPr>
+        <p:txBody>
+          <a:bodyPr/>
+          <a:p/>
+        </p:txBody>
       </p:sp>
       <p:sp>
         <p:nvSpPr>
@@ -49592,6 +50717,10 @@
             <a:prstDash val="solid"/>
           </a:ln>
         </p:spPr>
+        <p:txBody>
+          <a:bodyPr/>
+          <a:p/>
+        </p:txBody>
       </p:sp>
       <p:sp>
         <p:nvSpPr>
@@ -49699,6 +50828,10 @@
             <a:prstDash val="solid"/>
           </a:ln>
         </p:spPr>
+        <p:txBody>
+          <a:bodyPr/>
+          <a:p/>
+        </p:txBody>
       </p:sp>
       <p:sp>
         <p:nvSpPr>
@@ -49806,6 +50939,10 @@
             <a:prstDash val="solid"/>
           </a:ln>
         </p:spPr>
+        <p:txBody>
+          <a:bodyPr/>
+          <a:p/>
+        </p:txBody>
       </p:sp>
       <p:sp>
         <p:nvSpPr>
@@ -49913,6 +51050,10 @@
             <a:prstDash val="solid"/>
           </a:ln>
         </p:spPr>
+        <p:txBody>
+          <a:bodyPr/>
+          <a:p/>
+        </p:txBody>
       </p:sp>
       <p:sp>
         <p:nvSpPr>
@@ -50020,6 +51161,10 @@
             <a:prstDash val="solid"/>
           </a:ln>
         </p:spPr>
+        <p:txBody>
+          <a:bodyPr/>
+          <a:p/>
+        </p:txBody>
       </p:sp>
     </p:spTree>
   </p:cSld>
@@ -50070,6 +51215,10 @@
             <a:prstDash val="solid"/>
           </a:ln>
         </p:spPr>
+        <p:txBody>
+          <a:bodyPr/>
+          <a:p/>
+        </p:txBody>
       </p:sp>
       <p:sp>
         <p:nvSpPr>
@@ -50452,6 +51601,10 @@
             <a:prstDash val="solid"/>
           </a:ln>
         </p:spPr>
+        <p:txBody>
+          <a:bodyPr/>
+          <a:p/>
+        </p:txBody>
       </p:sp>
       <p:sp>
         <p:nvSpPr>
@@ -50559,6 +51712,10 @@
             <a:prstDash val="solid"/>
           </a:ln>
         </p:spPr>
+        <p:txBody>
+          <a:bodyPr/>
+          <a:p/>
+        </p:txBody>
       </p:sp>
       <p:sp>
         <p:nvSpPr>
@@ -50666,6 +51823,10 @@
             <a:prstDash val="solid"/>
           </a:ln>
         </p:spPr>
+        <p:txBody>
+          <a:bodyPr/>
+          <a:p/>
+        </p:txBody>
       </p:sp>
       <p:sp>
         <p:nvSpPr>
@@ -50773,6 +51934,10 @@
             <a:prstDash val="solid"/>
           </a:ln>
         </p:spPr>
+        <p:txBody>
+          <a:bodyPr/>
+          <a:p/>
+        </p:txBody>
       </p:sp>
       <p:sp>
         <p:nvSpPr>
@@ -50880,6 +52045,10 @@
             <a:prstDash val="solid"/>
           </a:ln>
         </p:spPr>
+        <p:txBody>
+          <a:bodyPr/>
+          <a:p/>
+        </p:txBody>
       </p:sp>
       <p:sp>
         <p:nvSpPr>
@@ -50987,6 +52156,10 @@
             <a:prstDash val="solid"/>
           </a:ln>
         </p:spPr>
+        <p:txBody>
+          <a:bodyPr/>
+          <a:p/>
+        </p:txBody>
       </p:sp>
       <p:sp>
         <p:nvSpPr>
@@ -51094,6 +52267,10 @@
             <a:prstDash val="solid"/>
           </a:ln>
         </p:spPr>
+        <p:txBody>
+          <a:bodyPr/>
+          <a:p/>
+        </p:txBody>
       </p:sp>
       <p:sp>
         <p:nvSpPr>
@@ -51201,6 +52378,10 @@
             <a:prstDash val="solid"/>
           </a:ln>
         </p:spPr>
+        <p:txBody>
+          <a:bodyPr/>
+          <a:p/>
+        </p:txBody>
       </p:sp>
     </p:spTree>
   </p:cSld>
@@ -51251,6 +52432,10 @@
             <a:prstDash val="solid"/>
           </a:ln>
         </p:spPr>
+        <p:txBody>
+          <a:bodyPr/>
+          <a:p/>
+        </p:txBody>
       </p:sp>
       <p:sp>
         <p:nvSpPr>
@@ -51684,6 +52869,10 @@
             <a:prstDash val="solid"/>
           </a:ln>
         </p:spPr>
+        <p:txBody>
+          <a:bodyPr/>
+          <a:p/>
+        </p:txBody>
       </p:sp>
       <p:sp>
         <p:nvSpPr>
@@ -51910,6 +53099,10 @@
             <a:prstDash val="solid"/>
           </a:ln>
         </p:spPr>
+        <p:txBody>
+          <a:bodyPr/>
+          <a:p/>
+        </p:txBody>
       </p:sp>
       <p:sp>
         <p:nvSpPr>
@@ -52019,6 +53212,10 @@
             <a:prstDash val="solid"/>
           </a:ln>
         </p:spPr>
+        <p:txBody>
+          <a:bodyPr/>
+          <a:p/>
+        </p:txBody>
       </p:sp>
       <p:sp>
         <p:nvSpPr>
@@ -52128,6 +53325,10 @@
             <a:prstDash val="solid"/>
           </a:ln>
         </p:spPr>
+        <p:txBody>
+          <a:bodyPr/>
+          <a:p/>
+        </p:txBody>
       </p:sp>
       <p:sp>
         <p:nvSpPr>
@@ -52237,6 +53438,10 @@
             <a:prstDash val="solid"/>
           </a:ln>
         </p:spPr>
+        <p:txBody>
+          <a:bodyPr/>
+          <a:p/>
+        </p:txBody>
       </p:sp>
       <p:sp>
         <p:nvSpPr>
@@ -52346,6 +53551,10 @@
             <a:prstDash val="solid"/>
           </a:ln>
         </p:spPr>
+        <p:txBody>
+          <a:bodyPr/>
+          <a:p/>
+        </p:txBody>
       </p:sp>
       <p:sp>
         <p:nvSpPr>
@@ -52455,6 +53664,10 @@
             <a:prstDash val="solid"/>
           </a:ln>
         </p:spPr>
+        <p:txBody>
+          <a:bodyPr/>
+          <a:p/>
+        </p:txBody>
       </p:sp>
       <p:sp>
         <p:nvSpPr>
@@ -52587,6 +53800,10 @@
             <a:prstDash val="solid"/>
           </a:ln>
         </p:spPr>
+        <p:txBody>
+          <a:bodyPr/>
+          <a:p/>
+        </p:txBody>
       </p:sp>
       <p:sp>
         <p:nvSpPr>
@@ -53027,6 +54244,10 @@
             <a:prstDash val="solid"/>
           </a:ln>
         </p:spPr>
+        <p:txBody>
+          <a:bodyPr/>
+          <a:p/>
+        </p:txBody>
       </p:sp>
       <p:sp>
         <p:nvSpPr>
@@ -53301,6 +54522,10 @@
             <a:prstDash val="solid"/>
           </a:ln>
         </p:spPr>
+        <p:txBody>
+          <a:bodyPr/>
+          <a:p/>
+        </p:txBody>
       </p:sp>
       <p:sp>
         <p:nvSpPr>
@@ -53683,6 +54908,10 @@
             <a:prstDash val="solid"/>
           </a:ln>
         </p:spPr>
+        <p:txBody>
+          <a:bodyPr/>
+          <a:p/>
+        </p:txBody>
       </p:sp>
       <p:sp>
         <p:nvSpPr>
@@ -53790,6 +55019,10 @@
             <a:prstDash val="solid"/>
           </a:ln>
         </p:spPr>
+        <p:txBody>
+          <a:bodyPr/>
+          <a:p/>
+        </p:txBody>
       </p:sp>
       <p:sp>
         <p:nvSpPr>
@@ -53897,6 +55130,10 @@
             <a:prstDash val="solid"/>
           </a:ln>
         </p:spPr>
+        <p:txBody>
+          <a:bodyPr/>
+          <a:p/>
+        </p:txBody>
       </p:sp>
       <p:sp>
         <p:nvSpPr>
@@ -54004,6 +55241,10 @@
             <a:prstDash val="solid"/>
           </a:ln>
         </p:spPr>
+        <p:txBody>
+          <a:bodyPr/>
+          <a:p/>
+        </p:txBody>
       </p:sp>
       <p:sp>
         <p:nvSpPr>
@@ -54111,6 +55352,10 @@
             <a:prstDash val="solid"/>
           </a:ln>
         </p:spPr>
+        <p:txBody>
+          <a:bodyPr/>
+          <a:p/>
+        </p:txBody>
       </p:sp>
       <p:sp>
         <p:nvSpPr>
@@ -54218,6 +55463,10 @@
             <a:prstDash val="solid"/>
           </a:ln>
         </p:spPr>
+        <p:txBody>
+          <a:bodyPr/>
+          <a:p/>
+        </p:txBody>
       </p:sp>
     </p:spTree>
   </p:cSld>
@@ -54268,6 +55517,10 @@
             <a:prstDash val="solid"/>
           </a:ln>
         </p:spPr>
+        <p:txBody>
+          <a:bodyPr/>
+          <a:p/>
+        </p:txBody>
       </p:sp>
       <p:sp>
         <p:nvSpPr>
@@ -54494,6 +55747,10 @@
             <a:prstDash val="solid"/>
           </a:ln>
         </p:spPr>
+        <p:txBody>
+          <a:bodyPr/>
+          <a:p/>
+        </p:txBody>
       </p:sp>
       <p:sp>
         <p:nvSpPr>
@@ -54603,6 +55860,10 @@
             <a:prstDash val="solid"/>
           </a:ln>
         </p:spPr>
+        <p:txBody>
+          <a:bodyPr/>
+          <a:p/>
+        </p:txBody>
       </p:sp>
       <p:sp>
         <p:nvSpPr>
@@ -54712,6 +55973,10 @@
             <a:prstDash val="solid"/>
           </a:ln>
         </p:spPr>
+        <p:txBody>
+          <a:bodyPr/>
+          <a:p/>
+        </p:txBody>
       </p:sp>
       <p:sp>
         <p:nvSpPr>
@@ -54821,6 +56086,10 @@
             <a:prstDash val="solid"/>
           </a:ln>
         </p:spPr>
+        <p:txBody>
+          <a:bodyPr/>
+          <a:p/>
+        </p:txBody>
       </p:sp>
       <p:sp>
         <p:nvSpPr>
@@ -54930,6 +56199,10 @@
             <a:prstDash val="solid"/>
           </a:ln>
         </p:spPr>
+        <p:txBody>
+          <a:bodyPr/>
+          <a:p/>
+        </p:txBody>
       </p:sp>
       <p:sp>
         <p:nvSpPr>
@@ -55039,6 +56312,10 @@
             <a:prstDash val="solid"/>
           </a:ln>
         </p:spPr>
+        <p:txBody>
+          <a:bodyPr/>
+          <a:p/>
+        </p:txBody>
       </p:sp>
       <p:sp>
         <p:nvSpPr>
@@ -55148,6 +56425,10 @@
             <a:prstDash val="solid"/>
           </a:ln>
         </p:spPr>
+        <p:txBody>
+          <a:bodyPr/>
+          <a:p/>
+        </p:txBody>
       </p:sp>
       <p:sp>
         <p:nvSpPr>
@@ -55257,6 +56538,10 @@
             <a:prstDash val="solid"/>
           </a:ln>
         </p:spPr>
+        <p:txBody>
+          <a:bodyPr/>
+          <a:p/>
+        </p:txBody>
       </p:sp>
       <p:sp>
         <p:nvSpPr>
@@ -55389,6 +56674,10 @@
             <a:prstDash val="solid"/>
           </a:ln>
         </p:spPr>
+        <p:txBody>
+          <a:bodyPr/>
+          <a:p/>
+        </p:txBody>
       </p:sp>
       <p:sp>
         <p:nvSpPr>
@@ -55497,15 +56786,7 @@
               <a:buNone/>
             </a:pPr>
             <a:r>
-              <a:rPr lang="en-US" sz="1550" dirty="0">
-                <a:solidFill>
-                  <a:srgbClr val="5A6B7A"/>
-                </a:solidFill>
-                <a:latin typeface="Aptos" pitchFamily="34" charset="0"/>
-                <a:ea typeface="Aptos" pitchFamily="34" charset="-122"/>
-                <a:cs typeface="Aptos" pitchFamily="34" charset="-120"/>
-              </a:rPr>
-              <a:t>Use simple tools first. Let the process teach the software.</a:t>
+              <a:t>Use the existing app first. Let the concierge pilot teach the next improvements.</a:t>
             </a:r>
             <a:endParaRPr lang="en-US" sz="1550" dirty="0"/>
           </a:p>

</xml_diff>